<commit_message>
Update thesis defense materials
- Recreated documentation/changelog.txt as a comprehensive changelog covering the thesis document, presentation deck, speaking script, repository housekeeping, and known remaining follow-ups.
- Included the staged thesis and presentation artifact updates so the Word and PowerPoint deliverables match the revised defense narrative and report corrections.
- Updated the speaking script to use a simpler motivation-first flow, expanded architecture narration, reduced implementation jargon, and cautious benchmark framing.
- Added _thesis_build to .gitignore to keep generated thesis build output out of version control.
</commit_message>
<xml_diff>
--- a/documentation/Projekt_43995.pptx
+++ b/documentation/Projekt_43995.pptx
@@ -5,44 +5,57 @@
     <p:sldMasterId id="2147483648" r:id="rId1"/>
   </p:sldMasterIdLst>
   <p:notesMasterIdLst>
-    <p:notesMasterId r:id="rId10"/>
+    <p:notesMasterId r:id="rId11"/>
   </p:notesMasterIdLst>
   <p:sldIdLst>
-    <p:sldId id="256" r:id="rId2"/>
-    <p:sldId id="257" r:id="rId3"/>
-    <p:sldId id="258" r:id="rId4"/>
-    <p:sldId id="259" r:id="rId5"/>
-    <p:sldId id="260" r:id="rId6"/>
-    <p:sldId id="261" r:id="rId7"/>
-    <p:sldId id="262" r:id="rId8"/>
-    <p:sldId id="263" r:id="rId9"/>
+    <p:sldId id="264" r:id="rId2"/>
+    <p:sldId id="258" r:id="rId3"/>
+    <p:sldId id="257" r:id="rId4"/>
+    <p:sldId id="260" r:id="rId5"/>
+    <p:sldId id="267" r:id="rId6"/>
+    <p:sldId id="259" r:id="rId7"/>
+    <p:sldId id="261" r:id="rId8"/>
+    <p:sldId id="262" r:id="rId9"/>
+    <p:sldId id="263" r:id="rId10"/>
   </p:sldIdLst>
   <p:sldSz cx="9144000" cy="5143500" type="screen16x9"/>
   <p:notesSz cx="5143500" cy="9144000"/>
   <p:embeddedFontLst>
     <p:embeddedFont>
-      <p:font typeface="Consolas" panose="020B0609020204030204" pitchFamily="49" charset="0"/>
-      <p:regular r:id="rId11"/>
-      <p:bold r:id="rId12"/>
-      <p:italic r:id="rId13"/>
-      <p:boldItalic r:id="rId14"/>
+      <p:font typeface="Georgia" panose="02040502050405020303" pitchFamily="18" charset="0"/>
+      <p:regular r:id="rId12"/>
+      <p:bold r:id="rId13"/>
+      <p:italic r:id="rId14"/>
+      <p:boldItalic r:id="rId15"/>
+    </p:embeddedFont>
+    <p:embeddedFont>
+      <p:font typeface="Montserrat" panose="00000500000000000000" pitchFamily="2" charset="0"/>
+      <p:regular r:id="rId16"/>
+      <p:bold r:id="rId17"/>
+      <p:italic r:id="rId18"/>
+      <p:boldItalic r:id="rId19"/>
+    </p:embeddedFont>
+    <p:embeddedFont>
+      <p:font typeface="Montserrat Medium" panose="00000600000000000000" pitchFamily="2" charset="0"/>
+      <p:regular r:id="rId20"/>
+      <p:italic r:id="rId21"/>
     </p:embeddedFont>
     <p:embeddedFont>
       <p:font typeface="Platypi Light" pitchFamily="2" charset="0"/>
-      <p:regular r:id="rId15"/>
-      <p:italic r:id="rId16"/>
+      <p:regular r:id="rId22"/>
+      <p:italic r:id="rId23"/>
     </p:embeddedFont>
     <p:embeddedFont>
       <p:font typeface="Platypi Medium" pitchFamily="2" charset="0"/>
-      <p:regular r:id="rId17"/>
-      <p:italic r:id="rId18"/>
+      <p:regular r:id="rId24"/>
+      <p:italic r:id="rId25"/>
     </p:embeddedFont>
     <p:embeddedFont>
       <p:font typeface="Source Serif 4" panose="02040603050405020204" pitchFamily="18" charset="0"/>
-      <p:regular r:id="rId19"/>
-      <p:bold r:id="rId20"/>
-      <p:italic r:id="rId21"/>
-      <p:boldItalic r:id="rId22"/>
+      <p:regular r:id="rId26"/>
+      <p:bold r:id="rId27"/>
+      <p:italic r:id="rId28"/>
+      <p:boldItalic r:id="rId29"/>
     </p:embeddedFont>
   </p:embeddedFontLst>
   <p:defaultTextStyle>
@@ -338,7 +351,7 @@
           <a:p>
             <a:fld id="{F7021451-1387-4CA6-816F-3879F97B5CBC}" type="slidenum">
               <a:rPr lang="en-US"/>
-              <a:t>1</a:t>
+              <a:t>2</a:t>
             </a:fld>
             <a:endParaRPr lang="en-US"/>
           </a:p>
@@ -422,7 +435,7 @@
           <a:p>
             <a:fld id="{F7021451-1387-4CA6-816F-3879F97B5CBC}" type="slidenum">
               <a:rPr lang="en-US"/>
-              <a:t>2</a:t>
+              <a:t>3</a:t>
             </a:fld>
             <a:endParaRPr lang="en-US"/>
           </a:p>
@@ -506,7 +519,7 @@
           <a:p>
             <a:fld id="{F7021451-1387-4CA6-816F-3879F97B5CBC}" type="slidenum">
               <a:rPr lang="en-US"/>
-              <a:t>3</a:t>
+              <a:t>4</a:t>
             </a:fld>
             <a:endParaRPr lang="en-US"/>
           </a:p>
@@ -590,7 +603,7 @@
           <a:p>
             <a:fld id="{F7021451-1387-4CA6-816F-3879F97B5CBC}" type="slidenum">
               <a:rPr lang="en-US"/>
-              <a:t>4</a:t>
+              <a:t>6</a:t>
             </a:fld>
             <a:endParaRPr lang="en-US"/>
           </a:p>
@@ -674,7 +687,7 @@
           <a:p>
             <a:fld id="{F7021451-1387-4CA6-816F-3879F97B5CBC}" type="slidenum">
               <a:rPr lang="en-US"/>
-              <a:t>5</a:t>
+              <a:t>7</a:t>
             </a:fld>
             <a:endParaRPr lang="en-US"/>
           </a:p>
@@ -758,7 +771,7 @@
           <a:p>
             <a:fld id="{F7021451-1387-4CA6-816F-3879F97B5CBC}" type="slidenum">
               <a:rPr lang="en-US"/>
-              <a:t>6</a:t>
+              <a:t>8</a:t>
             </a:fld>
             <a:endParaRPr lang="en-US"/>
           </a:p>
@@ -842,91 +855,7 @@
           <a:p>
             <a:fld id="{F7021451-1387-4CA6-816F-3879F97B5CBC}" type="slidenum">
               <a:rPr lang="en-US"/>
-              <a:t>7</a:t>
-            </a:fld>
-            <a:endParaRPr lang="en-US"/>
-          </a:p>
-        </p:txBody>
-      </p:sp>
-    </p:spTree>
-    <p:extLst>
-      <p:ext uri="{BB962C8B-B14F-4D97-AF65-F5344CB8AC3E}">
-        <p14:creationId xmlns:p14="http://schemas.microsoft.com/office/powerpoint/2010/main" val="1024086991"/>
-      </p:ext>
-    </p:extLst>
-  </p:cSld>
-  <p:clrMapOvr>
-    <a:masterClrMapping/>
-  </p:clrMapOvr>
-</p:notes>
-</file>
-
-<file path=ppt/notesSlides/notesSlide8.xml><?xml version="1.0" encoding="utf-8"?>
-<p:notes xmlns:a="http://schemas.openxmlformats.org/drawingml/2006/main" xmlns:r="http://schemas.openxmlformats.org/officeDocument/2006/relationships" xmlns:p="http://schemas.openxmlformats.org/presentationml/2006/main">
-  <p:cSld>
-    <p:spTree>
-      <p:nvGrpSpPr>
-        <p:cNvPr id="1" name=""/>
-        <p:cNvGrpSpPr/>
-        <p:nvPr/>
-      </p:nvGrpSpPr>
-      <p:grpSpPr>
-        <a:xfrm>
-          <a:off x="0" y="0"/>
-          <a:ext cx="0" cy="0"/>
-          <a:chOff x="0" y="0"/>
-          <a:chExt cx="0" cy="0"/>
-        </a:xfrm>
-      </p:grpSpPr>
-      <p:sp>
-        <p:nvSpPr>
-          <p:cNvPr id="2" name="Slide Image Placeholder 1"/>
-          <p:cNvSpPr>
-            <a:spLocks noGrp="1" noRot="1" noChangeAspect="1"/>
-          </p:cNvSpPr>
-          <p:nvPr>
-            <p:ph type="sldImg"/>
-          </p:nvPr>
-        </p:nvSpPr>
-        <p:spPr/>
-      </p:sp>
-      <p:sp>
-        <p:nvSpPr>
-          <p:cNvPr id="3" name="Notes Placeholder 2"/>
-          <p:cNvSpPr>
-            <a:spLocks noGrp="1"/>
-          </p:cNvSpPr>
-          <p:nvPr>
-            <p:ph type="body" idx="1"/>
-          </p:nvPr>
-        </p:nvSpPr>
-        <p:spPr/>
-        <p:txBody>
-          <a:bodyPr/>
-          <a:lstStyle/>
-          <a:p>
-            <a:endParaRPr lang="en-US" dirty="0"/>
-          </a:p>
-        </p:txBody>
-      </p:sp>
-      <p:sp>
-        <p:nvSpPr>
-          <p:cNvPr id="4" name="Slide Number Placeholder 3"/>
-          <p:cNvSpPr>
-            <a:spLocks noGrp="1"/>
-          </p:cNvSpPr>
-          <p:nvPr>
-            <p:ph type="sldNum" sz="quarter" idx="10"/>
-          </p:nvPr>
-        </p:nvSpPr>
-        <p:spPr/>
-        <p:txBody>
-          <a:bodyPr/>
-          <a:lstStyle/>
-          <a:p>
-            <a:fld id="{F7021451-1387-4CA6-816F-3879F97B5CBC}" type="slidenum">
-              <a:rPr lang="en-US"/>
-              <a:t>8</a:t>
+              <a:t>9</a:t>
             </a:fld>
             <a:endParaRPr lang="en-US"/>
           </a:p>
@@ -968,6 +897,537 @@
         </a:xfrm>
       </p:grpSpPr>
     </p:spTree>
+  </p:cSld>
+  <p:clrMapOvr>
+    <a:masterClrMapping/>
+  </p:clrMapOvr>
+</p:sldLayout>
+</file>
+
+<file path=ppt/slideLayouts/slideLayout10.xml><?xml version="1.0" encoding="utf-8"?>
+<p:sldLayout xmlns:a="http://schemas.openxmlformats.org/drawingml/2006/main" xmlns:r="http://schemas.openxmlformats.org/officeDocument/2006/relationships" xmlns:p="http://schemas.openxmlformats.org/presentationml/2006/main" userDrawn="1">
+  <p:cSld name="Title and Content">
+    <p:spTree>
+      <p:nvGrpSpPr>
+        <p:cNvPr id="1" name=""/>
+        <p:cNvGrpSpPr/>
+        <p:nvPr/>
+      </p:nvGrpSpPr>
+      <p:grpSpPr>
+        <a:xfrm>
+          <a:off x="0" y="0"/>
+          <a:ext cx="0" cy="0"/>
+          <a:chOff x="0" y="0"/>
+          <a:chExt cx="0" cy="0"/>
+        </a:xfrm>
+      </p:grpSpPr>
+      <p:sp>
+        <p:nvSpPr>
+          <p:cNvPr id="11" name="Picture Placeholder 13">
+            <a:extLst>
+              <a:ext uri="{FF2B5EF4-FFF2-40B4-BE49-F238E27FC236}">
+                <a16:creationId xmlns:a16="http://schemas.microsoft.com/office/drawing/2014/main" id="{109FC8B7-D987-C14E-AE5C-EBE3017B53D2}"/>
+              </a:ext>
+            </a:extLst>
+          </p:cNvPr>
+          <p:cNvSpPr>
+            <a:spLocks noGrp="1"/>
+          </p:cNvSpPr>
+          <p:nvPr>
+            <p:ph type="pic" sz="quarter" idx="11" hasCustomPrompt="1"/>
+          </p:nvPr>
+        </p:nvSpPr>
+        <p:spPr>
+          <a:xfrm>
+            <a:off x="2187978" y="598342"/>
+            <a:ext cx="1416953" cy="1544339"/>
+          </a:xfrm>
+          <a:pattFill prst="lgCheck">
+            <a:fgClr>
+              <a:srgbClr val="E8E6E0"/>
+            </a:fgClr>
+            <a:bgClr>
+              <a:schemeClr val="bg1"/>
+            </a:bgClr>
+          </a:pattFill>
+        </p:spPr>
+        <p:txBody>
+          <a:bodyPr anchor="ctr">
+            <a:normAutofit/>
+          </a:bodyPr>
+          <a:lstStyle>
+            <a:lvl1pPr marL="0" indent="0" algn="ctr">
+              <a:buNone/>
+              <a:defRPr sz="900" b="0" i="0">
+                <a:solidFill>
+                  <a:srgbClr val="254441"/>
+                </a:solidFill>
+                <a:latin typeface="Montserrat Medium" pitchFamily="2" charset="77"/>
+              </a:defRPr>
+            </a:lvl1pPr>
+          </a:lstStyle>
+          <a:p>
+            <a:r>
+              <a:rPr lang="en-US" dirty="0"/>
+              <a:t>add picture here</a:t>
+            </a:r>
+          </a:p>
+        </p:txBody>
+      </p:sp>
+      <p:sp>
+        <p:nvSpPr>
+          <p:cNvPr id="12" name="Picture Placeholder 13">
+            <a:extLst>
+              <a:ext uri="{FF2B5EF4-FFF2-40B4-BE49-F238E27FC236}">
+                <a16:creationId xmlns:a16="http://schemas.microsoft.com/office/drawing/2014/main" id="{F11B03CD-BB1E-8A48-9306-610C598ED547}"/>
+              </a:ext>
+            </a:extLst>
+          </p:cNvPr>
+          <p:cNvSpPr>
+            <a:spLocks noGrp="1"/>
+          </p:cNvSpPr>
+          <p:nvPr>
+            <p:ph type="pic" sz="quarter" idx="12" hasCustomPrompt="1"/>
+          </p:nvPr>
+        </p:nvSpPr>
+        <p:spPr>
+          <a:xfrm>
+            <a:off x="3902478" y="598342"/>
+            <a:ext cx="1416953" cy="1544339"/>
+          </a:xfrm>
+          <a:pattFill prst="lgCheck">
+            <a:fgClr>
+              <a:srgbClr val="E8E6E0"/>
+            </a:fgClr>
+            <a:bgClr>
+              <a:schemeClr val="bg1"/>
+            </a:bgClr>
+          </a:pattFill>
+        </p:spPr>
+        <p:txBody>
+          <a:bodyPr anchor="ctr">
+            <a:normAutofit/>
+          </a:bodyPr>
+          <a:lstStyle>
+            <a:lvl1pPr marL="0" indent="0" algn="ctr">
+              <a:buNone/>
+              <a:defRPr sz="900" b="0" i="0">
+                <a:solidFill>
+                  <a:srgbClr val="254441"/>
+                </a:solidFill>
+                <a:latin typeface="Montserrat Medium" pitchFamily="2" charset="77"/>
+              </a:defRPr>
+            </a:lvl1pPr>
+          </a:lstStyle>
+          <a:p>
+            <a:r>
+              <a:rPr lang="en-US" dirty="0"/>
+              <a:t>add picture here</a:t>
+            </a:r>
+          </a:p>
+        </p:txBody>
+      </p:sp>
+      <p:sp>
+        <p:nvSpPr>
+          <p:cNvPr id="13" name="Picture Placeholder 13">
+            <a:extLst>
+              <a:ext uri="{FF2B5EF4-FFF2-40B4-BE49-F238E27FC236}">
+                <a16:creationId xmlns:a16="http://schemas.microsoft.com/office/drawing/2014/main" id="{664219D4-7144-044E-A69E-B8E4E7D28CB6}"/>
+              </a:ext>
+            </a:extLst>
+          </p:cNvPr>
+          <p:cNvSpPr>
+            <a:spLocks noGrp="1"/>
+          </p:cNvSpPr>
+          <p:nvPr>
+            <p:ph type="pic" sz="quarter" idx="13" hasCustomPrompt="1"/>
+          </p:nvPr>
+        </p:nvSpPr>
+        <p:spPr>
+          <a:xfrm>
+            <a:off x="5573016" y="598342"/>
+            <a:ext cx="1416953" cy="1544339"/>
+          </a:xfrm>
+          <a:pattFill prst="lgCheck">
+            <a:fgClr>
+              <a:srgbClr val="E8E6E0"/>
+            </a:fgClr>
+            <a:bgClr>
+              <a:schemeClr val="bg1"/>
+            </a:bgClr>
+          </a:pattFill>
+        </p:spPr>
+        <p:txBody>
+          <a:bodyPr anchor="ctr">
+            <a:normAutofit/>
+          </a:bodyPr>
+          <a:lstStyle>
+            <a:lvl1pPr marL="0" indent="0" algn="ctr">
+              <a:buNone/>
+              <a:defRPr sz="900" b="0" i="0">
+                <a:solidFill>
+                  <a:srgbClr val="254441"/>
+                </a:solidFill>
+                <a:latin typeface="Montserrat Medium" pitchFamily="2" charset="77"/>
+              </a:defRPr>
+            </a:lvl1pPr>
+          </a:lstStyle>
+          <a:p>
+            <a:r>
+              <a:rPr lang="en-US" dirty="0"/>
+              <a:t>add picture here</a:t>
+            </a:r>
+          </a:p>
+        </p:txBody>
+      </p:sp>
+      <p:sp>
+        <p:nvSpPr>
+          <p:cNvPr id="14" name="Picture Placeholder 13">
+            <a:extLst>
+              <a:ext uri="{FF2B5EF4-FFF2-40B4-BE49-F238E27FC236}">
+                <a16:creationId xmlns:a16="http://schemas.microsoft.com/office/drawing/2014/main" id="{F1250C75-F322-CB48-9AA0-3F557E6896C6}"/>
+              </a:ext>
+            </a:extLst>
+          </p:cNvPr>
+          <p:cNvSpPr>
+            <a:spLocks noGrp="1"/>
+          </p:cNvSpPr>
+          <p:nvPr>
+            <p:ph type="pic" sz="quarter" idx="14" hasCustomPrompt="1"/>
+          </p:nvPr>
+        </p:nvSpPr>
+        <p:spPr>
+          <a:xfrm>
+            <a:off x="2187978" y="2365596"/>
+            <a:ext cx="1416953" cy="1544339"/>
+          </a:xfrm>
+          <a:pattFill prst="lgCheck">
+            <a:fgClr>
+              <a:srgbClr val="E8E6E0"/>
+            </a:fgClr>
+            <a:bgClr>
+              <a:schemeClr val="bg1"/>
+            </a:bgClr>
+          </a:pattFill>
+        </p:spPr>
+        <p:txBody>
+          <a:bodyPr anchor="ctr">
+            <a:normAutofit/>
+          </a:bodyPr>
+          <a:lstStyle>
+            <a:lvl1pPr marL="0" indent="0" algn="ctr">
+              <a:buNone/>
+              <a:defRPr sz="900" b="0" i="0">
+                <a:solidFill>
+                  <a:srgbClr val="254441"/>
+                </a:solidFill>
+                <a:latin typeface="Montserrat Medium" pitchFamily="2" charset="77"/>
+              </a:defRPr>
+            </a:lvl1pPr>
+          </a:lstStyle>
+          <a:p>
+            <a:r>
+              <a:rPr lang="en-US" dirty="0"/>
+              <a:t>add picture here</a:t>
+            </a:r>
+          </a:p>
+        </p:txBody>
+      </p:sp>
+      <p:sp>
+        <p:nvSpPr>
+          <p:cNvPr id="15" name="Picture Placeholder 13">
+            <a:extLst>
+              <a:ext uri="{FF2B5EF4-FFF2-40B4-BE49-F238E27FC236}">
+                <a16:creationId xmlns:a16="http://schemas.microsoft.com/office/drawing/2014/main" id="{B6DD091A-4D02-124E-ADF0-DF01A538F610}"/>
+              </a:ext>
+            </a:extLst>
+          </p:cNvPr>
+          <p:cNvSpPr>
+            <a:spLocks noGrp="1"/>
+          </p:cNvSpPr>
+          <p:nvPr>
+            <p:ph type="pic" sz="quarter" idx="15" hasCustomPrompt="1"/>
+          </p:nvPr>
+        </p:nvSpPr>
+        <p:spPr>
+          <a:xfrm>
+            <a:off x="3902478" y="2365596"/>
+            <a:ext cx="1416953" cy="1544339"/>
+          </a:xfrm>
+          <a:pattFill prst="lgCheck">
+            <a:fgClr>
+              <a:srgbClr val="E8E6E0"/>
+            </a:fgClr>
+            <a:bgClr>
+              <a:schemeClr val="bg1"/>
+            </a:bgClr>
+          </a:pattFill>
+        </p:spPr>
+        <p:txBody>
+          <a:bodyPr anchor="ctr">
+            <a:normAutofit/>
+          </a:bodyPr>
+          <a:lstStyle>
+            <a:lvl1pPr marL="0" indent="0" algn="ctr">
+              <a:buNone/>
+              <a:defRPr sz="900" b="0" i="0">
+                <a:solidFill>
+                  <a:srgbClr val="254441"/>
+                </a:solidFill>
+                <a:latin typeface="Montserrat Medium" pitchFamily="2" charset="77"/>
+              </a:defRPr>
+            </a:lvl1pPr>
+          </a:lstStyle>
+          <a:p>
+            <a:r>
+              <a:rPr lang="en-US" dirty="0"/>
+              <a:t>add picture here</a:t>
+            </a:r>
+          </a:p>
+        </p:txBody>
+      </p:sp>
+      <p:sp>
+        <p:nvSpPr>
+          <p:cNvPr id="16" name="Picture Placeholder 13">
+            <a:extLst>
+              <a:ext uri="{FF2B5EF4-FFF2-40B4-BE49-F238E27FC236}">
+                <a16:creationId xmlns:a16="http://schemas.microsoft.com/office/drawing/2014/main" id="{776B7907-ACBE-2344-A81D-5B90943320B4}"/>
+              </a:ext>
+            </a:extLst>
+          </p:cNvPr>
+          <p:cNvSpPr>
+            <a:spLocks noGrp="1"/>
+          </p:cNvSpPr>
+          <p:nvPr>
+            <p:ph type="pic" sz="quarter" idx="16" hasCustomPrompt="1"/>
+          </p:nvPr>
+        </p:nvSpPr>
+        <p:spPr>
+          <a:xfrm>
+            <a:off x="5573016" y="2365596"/>
+            <a:ext cx="1416953" cy="1544339"/>
+          </a:xfrm>
+          <a:pattFill prst="lgCheck">
+            <a:fgClr>
+              <a:srgbClr val="E8E6E0"/>
+            </a:fgClr>
+            <a:bgClr>
+              <a:schemeClr val="bg1"/>
+            </a:bgClr>
+          </a:pattFill>
+        </p:spPr>
+        <p:txBody>
+          <a:bodyPr anchor="ctr">
+            <a:normAutofit/>
+          </a:bodyPr>
+          <a:lstStyle>
+            <a:lvl1pPr marL="0" indent="0" algn="ctr">
+              <a:buNone/>
+              <a:defRPr sz="900" b="0" i="0">
+                <a:solidFill>
+                  <a:srgbClr val="254441"/>
+                </a:solidFill>
+                <a:latin typeface="Montserrat Medium" pitchFamily="2" charset="77"/>
+              </a:defRPr>
+            </a:lvl1pPr>
+          </a:lstStyle>
+          <a:p>
+            <a:r>
+              <a:rPr lang="en-US" dirty="0"/>
+              <a:t>add picture here</a:t>
+            </a:r>
+          </a:p>
+        </p:txBody>
+      </p:sp>
+      <p:sp>
+        <p:nvSpPr>
+          <p:cNvPr id="9" name="TextBox 8">
+            <a:extLst>
+              <a:ext uri="{FF2B5EF4-FFF2-40B4-BE49-F238E27FC236}">
+                <a16:creationId xmlns:a16="http://schemas.microsoft.com/office/drawing/2014/main" id="{C19455C6-512E-1843-86D6-F4807638BAF0}"/>
+              </a:ext>
+            </a:extLst>
+          </p:cNvPr>
+          <p:cNvSpPr txBox="1"/>
+          <p:nvPr userDrawn="1"/>
+        </p:nvSpPr>
+        <p:spPr>
+          <a:xfrm>
+            <a:off x="454429" y="4902452"/>
+            <a:ext cx="951401" cy="149977"/>
+          </a:xfrm>
+          <a:prstGeom prst="rect">
+            <a:avLst/>
+          </a:prstGeom>
+          <a:noFill/>
+        </p:spPr>
+        <p:txBody>
+          <a:bodyPr wrap="square" lIns="0" tIns="0" rIns="0" bIns="0" rtlCol="0">
+            <a:spAutoFit/>
+          </a:bodyPr>
+          <a:lstStyle/>
+          <a:p>
+            <a:pPr algn="ctr">
+              <a:lnSpc>
+                <a:spcPct val="130000"/>
+              </a:lnSpc>
+              <a:spcBef>
+                <a:spcPts val="750"/>
+              </a:spcBef>
+            </a:pPr>
+            <a:r>
+              <a:rPr lang="en-US" sz="825" b="1" dirty="0">
+                <a:solidFill>
+                  <a:schemeClr val="tx1">
+                    <a:lumMod val="85000"/>
+                    <a:lumOff val="15000"/>
+                  </a:schemeClr>
+                </a:solidFill>
+                <a:latin typeface="Montserrat" pitchFamily="2" charset="77"/>
+              </a:rPr>
+              <a:t>www.</a:t>
+            </a:r>
+            <a:r>
+              <a:rPr lang="pl-PL" sz="825" b="1" dirty="0">
+                <a:solidFill>
+                  <a:schemeClr val="tx1">
+                    <a:lumMod val="85000"/>
+                    <a:lumOff val="15000"/>
+                  </a:schemeClr>
+                </a:solidFill>
+                <a:latin typeface="Montserrat" pitchFamily="2" charset="77"/>
+              </a:rPr>
+              <a:t>vizja.pl</a:t>
+            </a:r>
+            <a:endParaRPr lang="en-US" sz="750" dirty="0">
+              <a:solidFill>
+                <a:schemeClr val="tx1">
+                  <a:lumMod val="85000"/>
+                  <a:lumOff val="15000"/>
+                </a:schemeClr>
+              </a:solidFill>
+              <a:latin typeface="Montserrat" pitchFamily="2" charset="77"/>
+            </a:endParaRPr>
+          </a:p>
+        </p:txBody>
+      </p:sp>
+      <p:sp>
+        <p:nvSpPr>
+          <p:cNvPr id="2" name="TextBox 9">
+            <a:extLst>
+              <a:ext uri="{FF2B5EF4-FFF2-40B4-BE49-F238E27FC236}">
+                <a16:creationId xmlns:a16="http://schemas.microsoft.com/office/drawing/2014/main" id="{10A38E2E-FD52-9B68-5174-66EA5D14F45C}"/>
+              </a:ext>
+            </a:extLst>
+          </p:cNvPr>
+          <p:cNvSpPr txBox="1"/>
+          <p:nvPr userDrawn="1"/>
+        </p:nvSpPr>
+        <p:spPr>
+          <a:xfrm>
+            <a:off x="4572000" y="4722754"/>
+            <a:ext cx="173236" cy="126958"/>
+          </a:xfrm>
+          <a:prstGeom prst="rect">
+            <a:avLst/>
+          </a:prstGeom>
+          <a:noFill/>
+        </p:spPr>
+        <p:txBody>
+          <a:bodyPr wrap="square" lIns="0" tIns="0" rIns="0" bIns="0" rtlCol="0">
+            <a:spAutoFit/>
+          </a:bodyPr>
+          <a:lstStyle/>
+          <a:p>
+            <a:fld id="{EB288C9E-C8EC-D74F-ACF6-550FE1A1877B}" type="slidenum">
+              <a:rPr lang="en-US" sz="825" b="1" i="0" smtClean="0">
+                <a:solidFill>
+                  <a:schemeClr val="tx1">
+                    <a:lumMod val="85000"/>
+                    <a:lumOff val="15000"/>
+                  </a:schemeClr>
+                </a:solidFill>
+                <a:latin typeface="Montserrat" pitchFamily="2" charset="77"/>
+              </a:rPr>
+              <a:t>‹#›</a:t>
+            </a:fld>
+            <a:endParaRPr lang="en-US" sz="825" b="1" i="0" dirty="0">
+              <a:solidFill>
+                <a:schemeClr val="tx1">
+                  <a:lumMod val="85000"/>
+                  <a:lumOff val="15000"/>
+                </a:schemeClr>
+              </a:solidFill>
+              <a:latin typeface="Montserrat" pitchFamily="2" charset="77"/>
+            </a:endParaRPr>
+          </a:p>
+        </p:txBody>
+      </p:sp>
+      <p:pic>
+        <p:nvPicPr>
+          <p:cNvPr id="3" name="Obraz 2">
+            <a:extLst>
+              <a:ext uri="{FF2B5EF4-FFF2-40B4-BE49-F238E27FC236}">
+                <a16:creationId xmlns:a16="http://schemas.microsoft.com/office/drawing/2014/main" id="{1861A9A2-3CD6-BF13-C34A-47FEF40B202B}"/>
+              </a:ext>
+            </a:extLst>
+          </p:cNvPr>
+          <p:cNvPicPr>
+            <a:picLocks noChangeAspect="1"/>
+          </p:cNvPicPr>
+          <p:nvPr userDrawn="1"/>
+        </p:nvPicPr>
+        <p:blipFill>
+          <a:blip r:embed="rId2"/>
+          <a:srcRect/>
+          <a:stretch/>
+        </p:blipFill>
+        <p:spPr>
+          <a:xfrm>
+            <a:off x="134683" y="4459533"/>
+            <a:ext cx="1590893" cy="461815"/>
+          </a:xfrm>
+          <a:prstGeom prst="rect">
+            <a:avLst/>
+          </a:prstGeom>
+        </p:spPr>
+      </p:pic>
+    </p:spTree>
+    <p:extLst>
+      <p:ext uri="{BB962C8B-B14F-4D97-AF65-F5344CB8AC3E}">
+        <p14:creationId xmlns:p14="http://schemas.microsoft.com/office/powerpoint/2010/main" val="492070759"/>
+      </p:ext>
+    </p:extLst>
+  </p:cSld>
+  <p:clrMapOvr>
+    <a:masterClrMapping/>
+  </p:clrMapOvr>
+</p:sldLayout>
+</file>
+
+<file path=ppt/slideLayouts/slideLayout11.xml><?xml version="1.0" encoding="utf-8"?>
+<p:sldLayout xmlns:a="http://schemas.openxmlformats.org/drawingml/2006/main" xmlns:r="http://schemas.openxmlformats.org/officeDocument/2006/relationships" xmlns:p="http://schemas.openxmlformats.org/presentationml/2006/main" type="blank">
+  <p:cSld name="Blank">
+    <p:spTree>
+      <p:nvGrpSpPr>
+        <p:cNvPr id="1" name=""/>
+        <p:cNvGrpSpPr/>
+        <p:nvPr/>
+      </p:nvGrpSpPr>
+      <p:grpSpPr>
+        <a:xfrm>
+          <a:off x="0" y="0"/>
+          <a:ext cx="0" cy="0"/>
+          <a:chOff x="0" y="0"/>
+          <a:chExt cx="0" cy="0"/>
+        </a:xfrm>
+      </p:grpSpPr>
+    </p:spTree>
+    <p:extLst>
+      <p:ext uri="{BB962C8B-B14F-4D97-AF65-F5344CB8AC3E}">
+        <p14:creationId xmlns:p14="http://schemas.microsoft.com/office/powerpoint/2010/main" val="2823623404"/>
+      </p:ext>
+    </p:extLst>
   </p:cSld>
   <p:clrMapOvr>
     <a:masterClrMapping/>
@@ -1802,6 +2262,8 @@
     <p:sldLayoutId id="2147483655" r:id="rId7"/>
     <p:sldLayoutId id="2147483656" r:id="rId8"/>
     <p:sldLayoutId id="2147483657" r:id="rId9"/>
+    <p:sldLayoutId id="2147483658" r:id="rId10"/>
+    <p:sldLayoutId id="2147483659" r:id="rId11"/>
   </p:sldLayoutIdLst>
   <p:hf sldNum="0" hdr="0" ftr="0" dt="0"/>
   <p:txStyles>
@@ -2058,8 +2520,273 @@
 </file>
 
 <file path=ppt/slides/slide1.xml><?xml version="1.0" encoding="utf-8"?>
+<p:sld xmlns:a="http://schemas.openxmlformats.org/drawingml/2006/main" xmlns:r="http://schemas.openxmlformats.org/officeDocument/2006/relationships" xmlns:p="http://schemas.openxmlformats.org/presentationml/2006/main">
+  <p:cSld>
+    <p:spTree>
+      <p:nvGrpSpPr>
+        <p:cNvPr id="1" name=""/>
+        <p:cNvGrpSpPr/>
+        <p:nvPr/>
+      </p:nvGrpSpPr>
+      <p:grpSpPr>
+        <a:xfrm>
+          <a:off x="0" y="0"/>
+          <a:ext cx="0" cy="0"/>
+          <a:chOff x="0" y="0"/>
+          <a:chExt cx="0" cy="0"/>
+        </a:xfrm>
+      </p:grpSpPr>
+      <p:sp>
+        <p:nvSpPr>
+          <p:cNvPr id="26" name="TextBox 25">
+            <a:extLst>
+              <a:ext uri="{FF2B5EF4-FFF2-40B4-BE49-F238E27FC236}">
+                <a16:creationId xmlns:a16="http://schemas.microsoft.com/office/drawing/2014/main" id="{CABD3DFD-46A8-1D4C-8C95-8E3D4268C4B8}"/>
+              </a:ext>
+            </a:extLst>
+          </p:cNvPr>
+          <p:cNvSpPr txBox="1"/>
+          <p:nvPr/>
+        </p:nvSpPr>
+        <p:spPr>
+          <a:xfrm>
+            <a:off x="409564" y="1006720"/>
+            <a:ext cx="7997836" cy="677108"/>
+          </a:xfrm>
+          <a:prstGeom prst="rect">
+            <a:avLst/>
+          </a:prstGeom>
+          <a:noFill/>
+        </p:spPr>
+        <p:txBody>
+          <a:bodyPr wrap="square" lIns="0" tIns="0" rIns="0" bIns="0" rtlCol="0">
+            <a:spAutoFit/>
+          </a:bodyPr>
+          <a:lstStyle/>
+          <a:p>
+            <a:r>
+              <a:rPr lang="pl-PL" sz="4400" b="1" dirty="0">
+                <a:solidFill>
+                  <a:srgbClr val="1F1F1F"/>
+                </a:solidFill>
+                <a:latin typeface="Platypi Medium" pitchFamily="2" charset="0"/>
+                <a:cs typeface="Platypi Medium" pitchFamily="2" charset="0"/>
+              </a:rPr>
+              <a:t>System detekcji manipulacji</a:t>
+            </a:r>
+            <a:endParaRPr lang="en-US" sz="4400" b="1" dirty="0">
+              <a:solidFill>
+                <a:srgbClr val="1F1F1F"/>
+              </a:solidFill>
+              <a:latin typeface="Platypi Medium" pitchFamily="2" charset="0"/>
+              <a:cs typeface="Platypi Medium" pitchFamily="2" charset="0"/>
+            </a:endParaRPr>
+          </a:p>
+        </p:txBody>
+      </p:sp>
+      <p:sp>
+        <p:nvSpPr>
+          <p:cNvPr id="35" name="Rectangle 34">
+            <a:extLst>
+              <a:ext uri="{FF2B5EF4-FFF2-40B4-BE49-F238E27FC236}">
+                <a16:creationId xmlns:a16="http://schemas.microsoft.com/office/drawing/2014/main" id="{2A154E1E-5264-0546-9451-86264FC84397}"/>
+              </a:ext>
+            </a:extLst>
+          </p:cNvPr>
+          <p:cNvSpPr/>
+          <p:nvPr/>
+        </p:nvSpPr>
+        <p:spPr>
+          <a:xfrm>
+            <a:off x="342900" y="3638145"/>
+            <a:ext cx="4229100" cy="747363"/>
+          </a:xfrm>
+          <a:prstGeom prst="rect">
+            <a:avLst/>
+          </a:prstGeom>
+          <a:solidFill>
+            <a:srgbClr val="FEBF00"/>
+          </a:solidFill>
+          <a:ln>
+            <a:noFill/>
+          </a:ln>
+        </p:spPr>
+        <p:style>
+          <a:lnRef idx="2">
+            <a:schemeClr val="accent1">
+              <a:shade val="50000"/>
+            </a:schemeClr>
+          </a:lnRef>
+          <a:fillRef idx="1">
+            <a:schemeClr val="accent1"/>
+          </a:fillRef>
+          <a:effectRef idx="0">
+            <a:schemeClr val="accent1"/>
+          </a:effectRef>
+          <a:fontRef idx="minor">
+            <a:schemeClr val="lt1"/>
+          </a:fontRef>
+        </p:style>
+        <p:txBody>
+          <a:bodyPr rtlCol="0" anchor="ctr"/>
+          <a:lstStyle/>
+          <a:p>
+            <a:pPr algn="ctr"/>
+            <a:endParaRPr lang="en-US" sz="1350"/>
+          </a:p>
+        </p:txBody>
+      </p:sp>
+      <p:sp>
+        <p:nvSpPr>
+          <p:cNvPr id="29" name="TextBox 28">
+            <a:extLst>
+              <a:ext uri="{FF2B5EF4-FFF2-40B4-BE49-F238E27FC236}">
+                <a16:creationId xmlns:a16="http://schemas.microsoft.com/office/drawing/2014/main" id="{5914D198-C77F-4E4B-A249-5E61262DD647}"/>
+              </a:ext>
+            </a:extLst>
+          </p:cNvPr>
+          <p:cNvSpPr txBox="1"/>
+          <p:nvPr/>
+        </p:nvSpPr>
+        <p:spPr>
+          <a:xfrm>
+            <a:off x="376232" y="3678401"/>
+            <a:ext cx="4162436" cy="666849"/>
+          </a:xfrm>
+          <a:prstGeom prst="rect">
+            <a:avLst/>
+          </a:prstGeom>
+          <a:noFill/>
+        </p:spPr>
+        <p:txBody>
+          <a:bodyPr wrap="square" lIns="0" tIns="0" rIns="0" bIns="0" rtlCol="0">
+            <a:spAutoFit/>
+          </a:bodyPr>
+          <a:lstStyle/>
+          <a:p>
+            <a:pPr>
+              <a:spcBef>
+                <a:spcPts val="750"/>
+              </a:spcBef>
+            </a:pPr>
+            <a:r>
+              <a:rPr lang="pl-PL" sz="1000" dirty="0">
+                <a:solidFill>
+                  <a:srgbClr val="504C49"/>
+                </a:solidFill>
+                <a:latin typeface="Source Serif 4" pitchFamily="34" charset="0"/>
+                <a:ea typeface="Source Serif 4" pitchFamily="34" charset="-122"/>
+              </a:rPr>
+              <a:t>Vadym Abrosimov | 43995</a:t>
+            </a:r>
+          </a:p>
+          <a:p>
+            <a:pPr>
+              <a:spcBef>
+                <a:spcPts val="750"/>
+              </a:spcBef>
+            </a:pPr>
+            <a:r>
+              <a:rPr lang="pl-PL" sz="1000" dirty="0">
+                <a:solidFill>
+                  <a:srgbClr val="504C49"/>
+                </a:solidFill>
+                <a:latin typeface="Source Serif 4" pitchFamily="34" charset="0"/>
+                <a:ea typeface="Source Serif 4" pitchFamily="34" charset="-122"/>
+              </a:rPr>
+              <a:t>Promotor: dr inż. Andrzej Burda</a:t>
+            </a:r>
+          </a:p>
+          <a:p>
+            <a:pPr>
+              <a:spcBef>
+                <a:spcPts val="750"/>
+              </a:spcBef>
+            </a:pPr>
+            <a:r>
+              <a:rPr lang="pl-PL" sz="1000" dirty="0">
+                <a:solidFill>
+                  <a:srgbClr val="504C49"/>
+                </a:solidFill>
+                <a:latin typeface="Source Serif 4" pitchFamily="34" charset="0"/>
+                <a:ea typeface="Source Serif 4" pitchFamily="34" charset="-122"/>
+              </a:rPr>
+              <a:t>Kierunek: Informatyka</a:t>
+            </a:r>
+            <a:endParaRPr lang="en-US" sz="1000" dirty="0">
+              <a:solidFill>
+                <a:srgbClr val="504C49"/>
+              </a:solidFill>
+              <a:latin typeface="Source Serif 4" pitchFamily="34" charset="0"/>
+              <a:ea typeface="Source Serif 4" pitchFamily="34" charset="-122"/>
+            </a:endParaRPr>
+          </a:p>
+        </p:txBody>
+      </p:sp>
+      <p:sp>
+        <p:nvSpPr>
+          <p:cNvPr id="2" name="TextBox 1">
+            <a:extLst>
+              <a:ext uri="{FF2B5EF4-FFF2-40B4-BE49-F238E27FC236}">
+                <a16:creationId xmlns:a16="http://schemas.microsoft.com/office/drawing/2014/main" id="{2B8C241D-3F15-118F-8C70-C19A460DF3A6}"/>
+              </a:ext>
+            </a:extLst>
+          </p:cNvPr>
+          <p:cNvSpPr txBox="1"/>
+          <p:nvPr/>
+        </p:nvSpPr>
+        <p:spPr>
+          <a:xfrm>
+            <a:off x="406400" y="1968500"/>
+            <a:ext cx="7874000" cy="353943"/>
+          </a:xfrm>
+          <a:prstGeom prst="rect">
+            <a:avLst/>
+          </a:prstGeom>
+          <a:noFill/>
+        </p:spPr>
+        <p:txBody>
+          <a:bodyPr vert="horz" rtlCol="0">
+            <a:spAutoFit/>
+          </a:bodyPr>
+          <a:lstStyle/>
+          <a:p>
+            <a:r>
+              <a:rPr lang="pl-PL" sz="1700" dirty="0">
+                <a:solidFill>
+                  <a:srgbClr val="333333"/>
+                </a:solidFill>
+                <a:latin typeface="Source Serif 4" panose="02040603050405020204" pitchFamily="18" charset="0"/>
+                <a:ea typeface="Source Serif 4" panose="02040603050405020204" pitchFamily="18" charset="0"/>
+              </a:rPr>
+              <a:t>System detekcji dezinformacji z wyjaśnialną sztuczną inteligencją (XAI)</a:t>
+            </a:r>
+            <a:endParaRPr lang="en-US" sz="1700" dirty="0">
+              <a:solidFill>
+                <a:srgbClr val="333333"/>
+              </a:solidFill>
+              <a:latin typeface="Source Serif 4" panose="02040603050405020204" pitchFamily="18" charset="0"/>
+              <a:ea typeface="Source Serif 4" panose="02040603050405020204" pitchFamily="18" charset="0"/>
+            </a:endParaRPr>
+          </a:p>
+        </p:txBody>
+      </p:sp>
+    </p:spTree>
+    <p:extLst>
+      <p:ext uri="{BB962C8B-B14F-4D97-AF65-F5344CB8AC3E}">
+        <p14:creationId xmlns:p14="http://schemas.microsoft.com/office/powerpoint/2010/main" val="2444184849"/>
+      </p:ext>
+    </p:extLst>
+  </p:cSld>
+  <p:clrMapOvr>
+    <a:masterClrMapping/>
+  </p:clrMapOvr>
+</p:sld>
+</file>
+
+<file path=ppt/slides/slide2.xml><?xml version="1.0" encoding="utf-8"?>
 <p:sld xmlns:a="http://schemas.openxmlformats.org/drawingml/2006/main" xmlns:r="http://schemas.openxmlformats.org/officeDocument/2006/relationships" xmlns:p="http://schemas.openxmlformats.org/presentationml/2006/main" showMasterSp="0">
-  <p:cSld name="Slide 1">
+  <p:cSld name="Slide 3">
     <p:bg>
       <p:bgPr>
         <a:solidFill>
@@ -2084,33 +2811,107 @@
       </p:grpSpPr>
       <p:sp>
         <p:nvSpPr>
-          <p:cNvPr id="2" name="Text 0"/>
-          <p:cNvSpPr/>
-          <p:nvPr/>
-        </p:nvSpPr>
-        <p:spPr>
-          <a:xfrm>
-            <a:off x="2799904" y="1476747"/>
-            <a:ext cx="3544119" cy="442987"/>
-          </a:xfrm>
-          <a:prstGeom prst="rect">
-            <a:avLst/>
+          <p:cNvPr id="2" name="Shape 0"/>
+          <p:cNvSpPr/>
+          <p:nvPr/>
+        </p:nvSpPr>
+        <p:spPr>
+          <a:xfrm>
+            <a:off x="496119" y="420291"/>
+            <a:ext cx="797198" cy="241176"/>
+          </a:xfrm>
+          <a:prstGeom prst="roundRect">
+            <a:avLst>
+              <a:gd name="adj" fmla="val 6348"/>
+            </a:avLst>
           </a:prstGeom>
           <a:noFill/>
+          <a:ln w="4763">
+            <a:solidFill>
+              <a:srgbClr val="3E2513"/>
+            </a:solidFill>
+            <a:prstDash val="solid"/>
+          </a:ln>
+        </p:spPr>
+        <p:txBody>
+          <a:bodyPr/>
+          <a:lstStyle/>
+          <a:p>
+            <a:endParaRPr lang="pl-PL" noProof="0" dirty="0"/>
+          </a:p>
+        </p:txBody>
+      </p:sp>
+      <p:sp>
+        <p:nvSpPr>
+          <p:cNvPr id="3" name="Text 1"/>
+          <p:cNvSpPr/>
+          <p:nvPr/>
+        </p:nvSpPr>
+        <p:spPr>
+          <a:xfrm>
+            <a:off x="577379" y="463302"/>
+            <a:ext cx="634678" cy="155153"/>
+          </a:xfrm>
+          <a:prstGeom prst="rect">
+            <a:avLst/>
+          </a:prstGeom>
+          <a:noFill/>
           <a:ln/>
         </p:spPr>
         <p:txBody>
           <a:bodyPr wrap="none" lIns="0" tIns="0" rIns="0" bIns="0" rtlCol="0" anchor="t"/>
           <a:lstStyle/>
           <a:p>
-            <a:pPr marL="0" indent="0" algn="ctr">
+            <a:pPr marL="0" indent="0" algn="l">
               <a:lnSpc>
-                <a:spcPts val="3450"/>
+                <a:spcPts val="1200"/>
               </a:lnSpc>
               <a:buNone/>
             </a:pPr>
             <a:r>
-              <a:rPr lang="en-US" sz="2750" dirty="0">
+              <a:rPr lang="pl-PL" sz="800" noProof="0" dirty="0">
+                <a:solidFill>
+                  <a:srgbClr val="3E2513"/>
+                </a:solidFill>
+                <a:latin typeface="Source Serif 4" pitchFamily="34" charset="0"/>
+                <a:ea typeface="Source Serif 4" pitchFamily="34" charset="-122"/>
+                <a:cs typeface="Source Serif 4" pitchFamily="34" charset="-120"/>
+              </a:rPr>
+              <a:t>MOTYWACJA</a:t>
+            </a:r>
+            <a:endParaRPr lang="pl-PL" sz="800" noProof="0" dirty="0"/>
+          </a:p>
+        </p:txBody>
+      </p:sp>
+      <p:sp>
+        <p:nvSpPr>
+          <p:cNvPr id="4" name="Text 2"/>
+          <p:cNvSpPr/>
+          <p:nvPr/>
+        </p:nvSpPr>
+        <p:spPr>
+          <a:xfrm>
+            <a:off x="496119" y="707380"/>
+            <a:ext cx="7370713" cy="398711"/>
+          </a:xfrm>
+          <a:prstGeom prst="rect">
+            <a:avLst/>
+          </a:prstGeom>
+          <a:noFill/>
+          <a:ln/>
+        </p:spPr>
+        <p:txBody>
+          <a:bodyPr wrap="none" lIns="0" tIns="0" rIns="0" bIns="0" rtlCol="0" anchor="t"/>
+          <a:lstStyle/>
+          <a:p>
+            <a:pPr marL="0" indent="0" algn="l">
+              <a:lnSpc>
+                <a:spcPts val="3100"/>
+              </a:lnSpc>
+              <a:buNone/>
+            </a:pPr>
+            <a:r>
+              <a:rPr lang="pl-PL" sz="2500" noProof="0" dirty="0">
                 <a:solidFill>
                   <a:srgbClr val="201B18"/>
                 </a:solidFill>
@@ -2118,22 +2919,85 @@
                 <a:ea typeface="Platypi Medium" pitchFamily="34" charset="-122"/>
                 <a:cs typeface="Platypi Medium" pitchFamily="34" charset="-120"/>
               </a:rPr>
-              <a:t>AntyDezinformator</a:t>
-            </a:r>
-            <a:endParaRPr lang="en-US" sz="2750" dirty="0"/>
-          </a:p>
-        </p:txBody>
-      </p:sp>
-      <p:sp>
-        <p:nvSpPr>
-          <p:cNvPr id="3" name="Text 1"/>
-          <p:cNvSpPr/>
-          <p:nvPr/>
-        </p:nvSpPr>
-        <p:spPr>
-          <a:xfrm>
-            <a:off x="496119" y="2203252"/>
-            <a:ext cx="8151763" cy="226814"/>
+              <a:t>Dlaczego istniejące rozwiązania nie wystarczą?</a:t>
+            </a:r>
+            <a:endParaRPr lang="pl-PL" sz="2500" noProof="0" dirty="0"/>
+          </a:p>
+        </p:txBody>
+      </p:sp>
+      <p:sp>
+        <p:nvSpPr>
+          <p:cNvPr id="5" name="Shape 3"/>
+          <p:cNvSpPr/>
+          <p:nvPr/>
+        </p:nvSpPr>
+        <p:spPr>
+          <a:xfrm>
+            <a:off x="496119" y="1407468"/>
+            <a:ext cx="4343400" cy="985614"/>
+          </a:xfrm>
+          <a:prstGeom prst="roundRect">
+            <a:avLst>
+              <a:gd name="adj" fmla="val 6958"/>
+            </a:avLst>
+          </a:prstGeom>
+          <a:solidFill>
+            <a:srgbClr val="FFFFFF"/>
+          </a:solidFill>
+          <a:ln w="14288">
+            <a:solidFill>
+              <a:srgbClr val="D8D4D4"/>
+            </a:solidFill>
+            <a:prstDash val="solid"/>
+          </a:ln>
+        </p:spPr>
+        <p:txBody>
+          <a:bodyPr/>
+          <a:lstStyle/>
+          <a:p>
+            <a:endParaRPr lang="pl-PL" noProof="0" dirty="0"/>
+          </a:p>
+        </p:txBody>
+      </p:sp>
+      <p:sp>
+        <p:nvSpPr>
+          <p:cNvPr id="6" name="Shape 4"/>
+          <p:cNvSpPr/>
+          <p:nvPr/>
+        </p:nvSpPr>
+        <p:spPr>
+          <a:xfrm>
+            <a:off x="481831" y="1407468"/>
+            <a:ext cx="57150" cy="985614"/>
+          </a:xfrm>
+          <a:prstGeom prst="roundRect">
+            <a:avLst>
+              <a:gd name="adj" fmla="val 33488"/>
+            </a:avLst>
+          </a:prstGeom>
+          <a:solidFill>
+            <a:srgbClr val="3E2513"/>
+          </a:solidFill>
+          <a:ln/>
+        </p:spPr>
+        <p:txBody>
+          <a:bodyPr/>
+          <a:lstStyle/>
+          <a:p>
+            <a:endParaRPr lang="pl-PL" noProof="0" dirty="0"/>
+          </a:p>
+        </p:txBody>
+      </p:sp>
+      <p:sp>
+        <p:nvSpPr>
+          <p:cNvPr id="7" name="Text 5"/>
+          <p:cNvSpPr/>
+          <p:nvPr/>
+        </p:nvSpPr>
+        <p:spPr>
+          <a:xfrm>
+            <a:off x="680814" y="1549301"/>
+            <a:ext cx="2310929" cy="199281"/>
           </a:xfrm>
           <a:prstGeom prst="rect">
             <a:avLst/>
@@ -2145,14 +3009,56 @@
           <a:bodyPr wrap="none" lIns="0" tIns="0" rIns="0" bIns="0" rtlCol="0" anchor="t"/>
           <a:lstStyle/>
           <a:p>
-            <a:pPr marL="0" indent="0" algn="ctr">
+            <a:pPr marL="0" indent="0" algn="l">
               <a:lnSpc>
-                <a:spcPts val="1750"/>
+                <a:spcPts val="1550"/>
               </a:lnSpc>
               <a:buNone/>
             </a:pPr>
             <a:r>
-              <a:rPr lang="en-US" sz="1100" dirty="0">
+              <a:rPr lang="pl-PL" sz="1250" noProof="0" dirty="0">
+                <a:solidFill>
+                  <a:srgbClr val="504C49"/>
+                </a:solidFill>
+                <a:latin typeface="Platypi Medium" pitchFamily="34" charset="0"/>
+                <a:ea typeface="Platypi Medium" pitchFamily="34" charset="-122"/>
+                <a:cs typeface="Platypi Medium" pitchFamily="34" charset="-120"/>
+              </a:rPr>
+              <a:t>BERT i modele klasyfikacyjne</a:t>
+            </a:r>
+            <a:endParaRPr lang="pl-PL" sz="1250" noProof="0" dirty="0"/>
+          </a:p>
+        </p:txBody>
+      </p:sp>
+      <p:sp>
+        <p:nvSpPr>
+          <p:cNvPr id="8" name="Text 6"/>
+          <p:cNvSpPr/>
+          <p:nvPr/>
+        </p:nvSpPr>
+        <p:spPr>
+          <a:xfrm>
+            <a:off x="680814" y="1863403"/>
+            <a:ext cx="4016871" cy="387846"/>
+          </a:xfrm>
+          <a:prstGeom prst="rect">
+            <a:avLst/>
+          </a:prstGeom>
+          <a:noFill/>
+          <a:ln/>
+        </p:spPr>
+        <p:txBody>
+          <a:bodyPr wrap="square" lIns="0" tIns="0" rIns="0" bIns="0" rtlCol="0" anchor="t"/>
+          <a:lstStyle/>
+          <a:p>
+            <a:pPr marL="0" indent="0" algn="l">
+              <a:lnSpc>
+                <a:spcPts val="1500"/>
+              </a:lnSpc>
+              <a:buNone/>
+            </a:pPr>
+            <a:r>
+              <a:rPr lang="pl-PL" sz="1000" noProof="0" dirty="0">
                 <a:solidFill>
                   <a:srgbClr val="504C49"/>
                 </a:solidFill>
@@ -2160,44 +3066,107 @@
                 <a:ea typeface="Source Serif 4" pitchFamily="34" charset="-122"/>
                 <a:cs typeface="Source Serif 4" pitchFamily="34" charset="-120"/>
               </a:rPr>
-              <a:t>System detekcji dezinformacji z wyjaśnialną sztuczną inteligencją (XAI)</a:t>
-            </a:r>
-            <a:endParaRPr lang="en-US" sz="1100" dirty="0"/>
-          </a:p>
-        </p:txBody>
-      </p:sp>
-      <p:sp>
-        <p:nvSpPr>
-          <p:cNvPr id="4" name="Shape 2"/>
-          <p:cNvSpPr/>
-          <p:nvPr/>
-        </p:nvSpPr>
-        <p:spPr>
-          <a:xfrm>
-            <a:off x="496119" y="2624956"/>
-            <a:ext cx="8151763" cy="10567"/>
-          </a:xfrm>
-          <a:prstGeom prst="rect">
-            <a:avLst/>
+              <a:t>Zwracają wyłącznie </a:t>
+            </a:r>
+            <a:r>
+              <a:rPr lang="pl-PL" sz="1000" b="1" noProof="0" dirty="0">
+                <a:solidFill>
+                  <a:srgbClr val="504C49"/>
+                </a:solidFill>
+                <a:latin typeface="Source Serif 4" pitchFamily="34" charset="0"/>
+                <a:ea typeface="Source Serif 4" pitchFamily="34" charset="-122"/>
+                <a:cs typeface="Source Serif 4" pitchFamily="34" charset="-120"/>
+              </a:rPr>
+              <a:t>wynik liczbowy</a:t>
+            </a:r>
+            <a:r>
+              <a:rPr lang="pl-PL" sz="1000" noProof="0" dirty="0">
+                <a:solidFill>
+                  <a:srgbClr val="504C49"/>
+                </a:solidFill>
+                <a:latin typeface="Source Serif 4" pitchFamily="34" charset="0"/>
+                <a:ea typeface="Source Serif 4" pitchFamily="34" charset="-122"/>
+                <a:cs typeface="Source Serif 4" pitchFamily="34" charset="-120"/>
+              </a:rPr>
+              <a:t> — brak jakiegokolwiek wyjaśnienia podjętej decyzji.</a:t>
+            </a:r>
+            <a:endParaRPr lang="pl-PL" sz="1000" noProof="0" dirty="0"/>
+          </a:p>
+        </p:txBody>
+      </p:sp>
+      <p:sp>
+        <p:nvSpPr>
+          <p:cNvPr id="9" name="Shape 7"/>
+          <p:cNvSpPr/>
+          <p:nvPr/>
+        </p:nvSpPr>
+        <p:spPr>
+          <a:xfrm>
+            <a:off x="496119" y="2507903"/>
+            <a:ext cx="4343400" cy="985614"/>
+          </a:xfrm>
+          <a:prstGeom prst="roundRect">
+            <a:avLst>
+              <a:gd name="adj" fmla="val 6958"/>
+            </a:avLst>
           </a:prstGeom>
           <a:solidFill>
-            <a:srgbClr val="504C49">
-              <a:alpha val="50000"/>
-            </a:srgbClr>
+            <a:srgbClr val="FFFFFF"/>
           </a:solidFill>
-          <a:ln/>
-        </p:spPr>
-      </p:sp>
-      <p:sp>
-        <p:nvSpPr>
-          <p:cNvPr id="5" name="Text 3"/>
-          <p:cNvSpPr/>
-          <p:nvPr/>
-        </p:nvSpPr>
-        <p:spPr>
-          <a:xfrm>
-            <a:off x="496119" y="2957959"/>
-            <a:ext cx="3902943" cy="226814"/>
+          <a:ln w="14288">
+            <a:solidFill>
+              <a:srgbClr val="D8D4D4"/>
+            </a:solidFill>
+            <a:prstDash val="solid"/>
+          </a:ln>
+        </p:spPr>
+        <p:txBody>
+          <a:bodyPr/>
+          <a:lstStyle/>
+          <a:p>
+            <a:endParaRPr lang="pl-PL" noProof="0" dirty="0"/>
+          </a:p>
+        </p:txBody>
+      </p:sp>
+      <p:sp>
+        <p:nvSpPr>
+          <p:cNvPr id="10" name="Shape 8"/>
+          <p:cNvSpPr/>
+          <p:nvPr/>
+        </p:nvSpPr>
+        <p:spPr>
+          <a:xfrm>
+            <a:off x="481831" y="2507903"/>
+            <a:ext cx="57150" cy="985614"/>
+          </a:xfrm>
+          <a:prstGeom prst="roundRect">
+            <a:avLst>
+              <a:gd name="adj" fmla="val 33488"/>
+            </a:avLst>
+          </a:prstGeom>
+          <a:solidFill>
+            <a:srgbClr val="3E2513"/>
+          </a:solidFill>
+          <a:ln/>
+        </p:spPr>
+        <p:txBody>
+          <a:bodyPr/>
+          <a:lstStyle/>
+          <a:p>
+            <a:endParaRPr lang="pl-PL" noProof="0" dirty="0"/>
+          </a:p>
+        </p:txBody>
+      </p:sp>
+      <p:sp>
+        <p:nvSpPr>
+          <p:cNvPr id="11" name="Text 9"/>
+          <p:cNvSpPr/>
+          <p:nvPr/>
+        </p:nvSpPr>
+        <p:spPr>
+          <a:xfrm>
+            <a:off x="680814" y="2649736"/>
+            <a:ext cx="2068041" cy="199281"/>
           </a:xfrm>
           <a:prstGeom prst="rect">
             <a:avLst/>
@@ -2211,12 +3180,53 @@
           <a:p>
             <a:pPr marL="0" indent="0" algn="l">
               <a:lnSpc>
-                <a:spcPts val="1750"/>
+                <a:spcPts val="1550"/>
               </a:lnSpc>
               <a:buNone/>
             </a:pPr>
             <a:r>
-              <a:rPr lang="en-US" sz="1100" b="1" dirty="0">
+              <a:rPr lang="pl-PL" sz="1250" noProof="0" dirty="0">
+                <a:solidFill>
+                  <a:srgbClr val="504C49"/>
+                </a:solidFill>
+                <a:latin typeface="Platypi Medium" pitchFamily="34" charset="0"/>
+                <a:ea typeface="Platypi Medium" pitchFamily="34" charset="-122"/>
+                <a:cs typeface="Platypi Medium" pitchFamily="34" charset="-120"/>
+              </a:rPr>
+              <a:t>GPT-4 i modele chmurowe</a:t>
+            </a:r>
+            <a:endParaRPr lang="pl-PL" sz="1250" noProof="0" dirty="0"/>
+          </a:p>
+        </p:txBody>
+      </p:sp>
+      <p:sp>
+        <p:nvSpPr>
+          <p:cNvPr id="12" name="Text 10"/>
+          <p:cNvSpPr/>
+          <p:nvPr/>
+        </p:nvSpPr>
+        <p:spPr>
+          <a:xfrm>
+            <a:off x="680814" y="2963838"/>
+            <a:ext cx="4016871" cy="387846"/>
+          </a:xfrm>
+          <a:prstGeom prst="rect">
+            <a:avLst/>
+          </a:prstGeom>
+          <a:noFill/>
+          <a:ln/>
+        </p:spPr>
+        <p:txBody>
+          <a:bodyPr wrap="square" lIns="0" tIns="0" rIns="0" bIns="0" rtlCol="0" anchor="t"/>
+          <a:lstStyle/>
+          <a:p>
+            <a:pPr>
+              <a:lnSpc>
+                <a:spcPts val="1500"/>
+              </a:lnSpc>
+            </a:pPr>
+            <a:r>
+              <a:rPr lang="pl-PL" sz="1000" noProof="0" dirty="0">
                 <a:solidFill>
                   <a:srgbClr val="504C49"/>
                 </a:solidFill>
@@ -2224,10 +3234,10 @@
                 <a:ea typeface="Source Serif 4" pitchFamily="34" charset="-122"/>
                 <a:cs typeface="Source Serif 4" pitchFamily="34" charset="-120"/>
               </a:rPr>
-              <a:t>Autor:</a:t>
-            </a:r>
-            <a:r>
-              <a:rPr lang="en-US" sz="1100" dirty="0">
+              <a:t>Ograniczenia moderacji treści, </a:t>
+            </a:r>
+            <a:r>
+              <a:rPr lang="pl-PL" sz="1000" b="1" noProof="0" dirty="0">
                 <a:solidFill>
                   <a:srgbClr val="504C49"/>
                 </a:solidFill>
@@ -2235,22 +3245,96 @@
                 <a:ea typeface="Source Serif 4" pitchFamily="34" charset="-122"/>
                 <a:cs typeface="Source Serif 4" pitchFamily="34" charset="-120"/>
               </a:rPr>
-              <a:t> Vadym Abrosimov</a:t>
-            </a:r>
-            <a:endParaRPr lang="en-US" sz="1100" dirty="0"/>
-          </a:p>
-        </p:txBody>
-      </p:sp>
-      <p:sp>
-        <p:nvSpPr>
-          <p:cNvPr id="6" name="Text 4"/>
-          <p:cNvSpPr/>
-          <p:nvPr/>
-        </p:nvSpPr>
-        <p:spPr>
-          <a:xfrm>
-            <a:off x="496119" y="3312319"/>
-            <a:ext cx="3902943" cy="226814"/>
+              <a:t>wysokie koszty API</a:t>
+            </a:r>
+            <a:r>
+              <a:rPr lang="pl-PL" sz="1000" noProof="0" dirty="0">
+                <a:solidFill>
+                  <a:srgbClr val="504C49"/>
+                </a:solidFill>
+                <a:latin typeface="Source Serif 4" pitchFamily="34" charset="0"/>
+                <a:ea typeface="Source Serif 4" pitchFamily="34" charset="-122"/>
+                <a:cs typeface="Source Serif 4" pitchFamily="34" charset="-120"/>
+              </a:rPr>
+              <a:t> oraz ryzyko naruszenia prywatności danych.</a:t>
+            </a:r>
+            <a:endParaRPr lang="pl-PL" sz="1000" noProof="0" dirty="0"/>
+          </a:p>
+        </p:txBody>
+      </p:sp>
+      <p:sp>
+        <p:nvSpPr>
+          <p:cNvPr id="13" name="Shape 11"/>
+          <p:cNvSpPr/>
+          <p:nvPr/>
+        </p:nvSpPr>
+        <p:spPr>
+          <a:xfrm>
+            <a:off x="496119" y="3608338"/>
+            <a:ext cx="4343400" cy="985614"/>
+          </a:xfrm>
+          <a:prstGeom prst="roundRect">
+            <a:avLst>
+              <a:gd name="adj" fmla="val 6958"/>
+            </a:avLst>
+          </a:prstGeom>
+          <a:solidFill>
+            <a:srgbClr val="FFFFFF"/>
+          </a:solidFill>
+          <a:ln w="14288">
+            <a:solidFill>
+              <a:srgbClr val="D8D4D4"/>
+            </a:solidFill>
+            <a:prstDash val="solid"/>
+          </a:ln>
+        </p:spPr>
+        <p:txBody>
+          <a:bodyPr/>
+          <a:lstStyle/>
+          <a:p>
+            <a:endParaRPr lang="pl-PL" noProof="0" dirty="0"/>
+          </a:p>
+        </p:txBody>
+      </p:sp>
+      <p:sp>
+        <p:nvSpPr>
+          <p:cNvPr id="14" name="Shape 12"/>
+          <p:cNvSpPr/>
+          <p:nvPr/>
+        </p:nvSpPr>
+        <p:spPr>
+          <a:xfrm>
+            <a:off x="481831" y="3608338"/>
+            <a:ext cx="57150" cy="985614"/>
+          </a:xfrm>
+          <a:prstGeom prst="roundRect">
+            <a:avLst>
+              <a:gd name="adj" fmla="val 33488"/>
+            </a:avLst>
+          </a:prstGeom>
+          <a:solidFill>
+            <a:srgbClr val="3E2513"/>
+          </a:solidFill>
+          <a:ln/>
+        </p:spPr>
+        <p:txBody>
+          <a:bodyPr/>
+          <a:lstStyle/>
+          <a:p>
+            <a:endParaRPr lang="pl-PL" noProof="0" dirty="0"/>
+          </a:p>
+        </p:txBody>
+      </p:sp>
+      <p:sp>
+        <p:nvSpPr>
+          <p:cNvPr id="15" name="Text 13"/>
+          <p:cNvSpPr/>
+          <p:nvPr/>
+        </p:nvSpPr>
+        <p:spPr>
+          <a:xfrm>
+            <a:off x="680814" y="3750171"/>
+            <a:ext cx="1660252" cy="199281"/>
           </a:xfrm>
           <a:prstGeom prst="rect">
             <a:avLst/>
@@ -2264,12 +3348,54 @@
           <a:p>
             <a:pPr marL="0" indent="0" algn="l">
               <a:lnSpc>
-                <a:spcPts val="1750"/>
+                <a:spcPts val="1550"/>
               </a:lnSpc>
               <a:buNone/>
             </a:pPr>
             <a:r>
-              <a:rPr lang="en-US" sz="1100" b="1" dirty="0">
+              <a:rPr lang="pl-PL" sz="1250" noProof="0" dirty="0">
+                <a:solidFill>
+                  <a:srgbClr val="504C49"/>
+                </a:solidFill>
+                <a:latin typeface="Platypi Medium" pitchFamily="34" charset="0"/>
+                <a:ea typeface="Platypi Medium" pitchFamily="34" charset="-122"/>
+                <a:cs typeface="Platypi Medium" pitchFamily="34" charset="-120"/>
+              </a:rPr>
+              <a:t>Ręczny fact-checking</a:t>
+            </a:r>
+            <a:endParaRPr lang="pl-PL" sz="1250" noProof="0" dirty="0"/>
+          </a:p>
+        </p:txBody>
+      </p:sp>
+      <p:sp>
+        <p:nvSpPr>
+          <p:cNvPr id="16" name="Text 14"/>
+          <p:cNvSpPr/>
+          <p:nvPr/>
+        </p:nvSpPr>
+        <p:spPr>
+          <a:xfrm>
+            <a:off x="680814" y="4064273"/>
+            <a:ext cx="4016871" cy="387846"/>
+          </a:xfrm>
+          <a:prstGeom prst="rect">
+            <a:avLst/>
+          </a:prstGeom>
+          <a:noFill/>
+          <a:ln/>
+        </p:spPr>
+        <p:txBody>
+          <a:bodyPr wrap="square" lIns="0" tIns="0" rIns="0" bIns="0" rtlCol="0" anchor="t"/>
+          <a:lstStyle/>
+          <a:p>
+            <a:pPr marL="0" indent="0" algn="l">
+              <a:lnSpc>
+                <a:spcPts val="1500"/>
+              </a:lnSpc>
+              <a:buNone/>
+            </a:pPr>
+            <a:r>
+              <a:rPr lang="pl-PL" sz="1000" noProof="0" dirty="0">
                 <a:solidFill>
                   <a:srgbClr val="504C49"/>
                 </a:solidFill>
@@ -2277,10 +3403,10 @@
                 <a:ea typeface="Source Serif 4" pitchFamily="34" charset="-122"/>
                 <a:cs typeface="Source Serif 4" pitchFamily="34" charset="-120"/>
               </a:rPr>
-              <a:t>Promotor:</a:t>
-            </a:r>
-            <a:r>
-              <a:rPr lang="en-US" sz="1100" dirty="0">
+              <a:t>Weryfikacja jednego artykułu zajmuje </a:t>
+            </a:r>
+            <a:r>
+              <a:rPr lang="pl-PL" sz="1000" b="1" noProof="0" dirty="0">
                 <a:solidFill>
                   <a:srgbClr val="504C49"/>
                 </a:solidFill>
@@ -2288,22 +3414,62 @@
                 <a:ea typeface="Source Serif 4" pitchFamily="34" charset="-122"/>
                 <a:cs typeface="Source Serif 4" pitchFamily="34" charset="-120"/>
               </a:rPr>
-              <a:t> dr inż. Andrzej Burda</a:t>
-            </a:r>
-            <a:endParaRPr lang="en-US" sz="1100" dirty="0"/>
-          </a:p>
-        </p:txBody>
-      </p:sp>
-      <p:sp>
-        <p:nvSpPr>
-          <p:cNvPr id="7" name="Text 5"/>
-          <p:cNvSpPr/>
-          <p:nvPr/>
-        </p:nvSpPr>
-        <p:spPr>
-          <a:xfrm>
-            <a:off x="4749701" y="2957959"/>
-            <a:ext cx="3902943" cy="226814"/>
+              <a:t>godziny pracy</a:t>
+            </a:r>
+            <a:r>
+              <a:rPr lang="pl-PL" sz="1000" noProof="0" dirty="0">
+                <a:solidFill>
+                  <a:srgbClr val="504C49"/>
+                </a:solidFill>
+                <a:latin typeface="Source Serif 4" pitchFamily="34" charset="0"/>
+                <a:ea typeface="Source Serif 4" pitchFamily="34" charset="-122"/>
+                <a:cs typeface="Source Serif 4" pitchFamily="34" charset="-120"/>
+              </a:rPr>
+              <a:t> eksperta — metoda całkowicie nieskalo­walna.</a:t>
+            </a:r>
+            <a:endParaRPr lang="pl-PL" sz="1000" noProof="0" dirty="0"/>
+          </a:p>
+        </p:txBody>
+      </p:sp>
+      <p:sp>
+        <p:nvSpPr>
+          <p:cNvPr id="17" name="Shape 15"/>
+          <p:cNvSpPr/>
+          <p:nvPr/>
+        </p:nvSpPr>
+        <p:spPr>
+          <a:xfrm>
+            <a:off x="5063654" y="1278285"/>
+            <a:ext cx="3680743" cy="3444850"/>
+          </a:xfrm>
+          <a:prstGeom prst="roundRect">
+            <a:avLst>
+              <a:gd name="adj" fmla="val 556"/>
+            </a:avLst>
+          </a:prstGeom>
+          <a:solidFill>
+            <a:srgbClr val="1A3A52"/>
+          </a:solidFill>
+          <a:ln/>
+        </p:spPr>
+        <p:txBody>
+          <a:bodyPr/>
+          <a:lstStyle/>
+          <a:p>
+            <a:endParaRPr lang="pl-PL" noProof="0" dirty="0"/>
+          </a:p>
+        </p:txBody>
+      </p:sp>
+      <p:sp>
+        <p:nvSpPr>
+          <p:cNvPr id="18" name="Text 16"/>
+          <p:cNvSpPr/>
+          <p:nvPr/>
+        </p:nvSpPr>
+        <p:spPr>
+          <a:xfrm>
+            <a:off x="5191199" y="1393106"/>
+            <a:ext cx="1615008" cy="199281"/>
           </a:xfrm>
           <a:prstGeom prst="rect">
             <a:avLst/>
@@ -2317,33 +3483,64 @@
           <a:p>
             <a:pPr marL="0" indent="0" algn="l">
               <a:lnSpc>
-                <a:spcPts val="1750"/>
+                <a:spcPts val="1550"/>
               </a:lnSpc>
               <a:buNone/>
             </a:pPr>
             <a:r>
-              <a:rPr lang="en-US" sz="1100" b="1" dirty="0">
-                <a:solidFill>
-                  <a:srgbClr val="504C49"/>
+              <a:rPr lang="pl-PL" sz="1250" noProof="0" dirty="0">
+                <a:solidFill>
+                  <a:srgbClr val="FFFFFF"/>
+                </a:solidFill>
+                <a:latin typeface="Platypi Medium" pitchFamily="34" charset="0"/>
+                <a:ea typeface="Platypi Medium" pitchFamily="34" charset="-122"/>
+                <a:cs typeface="Platypi Medium" pitchFamily="34" charset="-120"/>
+              </a:rPr>
+              <a:t>Luka technologiczna</a:t>
+            </a:r>
+            <a:endParaRPr lang="pl-PL" sz="1250" noProof="0" dirty="0"/>
+          </a:p>
+        </p:txBody>
+      </p:sp>
+      <p:sp>
+        <p:nvSpPr>
+          <p:cNvPr id="19" name="Text 17"/>
+          <p:cNvSpPr/>
+          <p:nvPr/>
+        </p:nvSpPr>
+        <p:spPr>
+          <a:xfrm>
+            <a:off x="5191199" y="1707207"/>
+            <a:ext cx="3425651" cy="581769"/>
+          </a:xfrm>
+          <a:prstGeom prst="rect">
+            <a:avLst/>
+          </a:prstGeom>
+          <a:noFill/>
+          <a:ln/>
+        </p:spPr>
+        <p:txBody>
+          <a:bodyPr wrap="square" lIns="0" tIns="0" rIns="0" bIns="0" rtlCol="0" anchor="t"/>
+          <a:lstStyle/>
+          <a:p>
+            <a:pPr marL="0" indent="0" algn="l">
+              <a:lnSpc>
+                <a:spcPts val="1500"/>
+              </a:lnSpc>
+              <a:buNone/>
+            </a:pPr>
+            <a:r>
+              <a:rPr lang="pl-PL" sz="1000" noProof="0" dirty="0">
+                <a:solidFill>
+                  <a:srgbClr val="FFFFFF"/>
                 </a:solidFill>
                 <a:latin typeface="Source Serif 4" pitchFamily="34" charset="0"/>
                 <a:ea typeface="Source Serif 4" pitchFamily="34" charset="-122"/>
                 <a:cs typeface="Source Serif 4" pitchFamily="34" charset="-120"/>
               </a:rPr>
-              <a:t>Typ:</a:t>
-            </a:r>
-            <a:r>
-              <a:rPr lang="en-US" sz="1100" dirty="0">
-                <a:solidFill>
-                  <a:srgbClr val="504C49"/>
-                </a:solidFill>
-                <a:latin typeface="Source Serif 4" pitchFamily="34" charset="0"/>
-                <a:ea typeface="Source Serif 4" pitchFamily="34" charset="-122"/>
-                <a:cs typeface="Source Serif 4" pitchFamily="34" charset="-120"/>
-              </a:rPr>
-              <a:t> Praca inżynierska</a:t>
-            </a:r>
-            <a:endParaRPr lang="en-US" sz="1100" dirty="0"/>
+              <a:t>Żadne z dostępnych rozwiązań nie łączy jednocześnie: lokalnego wdrożenia, wyjaśnialności oraz adaptacji do nowych danych bez zewnętrznych zależności.</a:t>
+            </a:r>
+            <a:endParaRPr lang="pl-PL" sz="1000" noProof="0" dirty="0"/>
           </a:p>
         </p:txBody>
       </p:sp>
@@ -2355,7 +3552,7 @@
 </p:sld>
 </file>
 
-<file path=ppt/slides/slide2.xml><?xml version="1.0" encoding="utf-8"?>
+<file path=ppt/slides/slide3.xml><?xml version="1.0" encoding="utf-8"?>
 <p:sld xmlns:a="http://schemas.openxmlformats.org/drawingml/2006/main" xmlns:r="http://schemas.openxmlformats.org/officeDocument/2006/relationships" xmlns:p="http://schemas.openxmlformats.org/presentationml/2006/main" showMasterSp="0">
   <p:cSld name="Slide 2">
     <p:bg>
@@ -2401,6 +3598,13 @@
           </a:solidFill>
           <a:ln/>
         </p:spPr>
+        <p:txBody>
+          <a:bodyPr/>
+          <a:lstStyle/>
+          <a:p>
+            <a:endParaRPr lang="pl-PL" noProof="0" dirty="0"/>
+          </a:p>
+        </p:txBody>
       </p:sp>
       <p:sp>
         <p:nvSpPr>
@@ -2430,7 +3634,7 @@
               <a:buNone/>
             </a:pPr>
             <a:r>
-              <a:rPr lang="en-US" sz="850" dirty="0">
+              <a:rPr lang="pl-PL" sz="850" noProof="0" dirty="0">
                 <a:solidFill>
                   <a:srgbClr val="504C49"/>
                 </a:solidFill>
@@ -2440,7 +3644,7 @@
               </a:rPr>
               <a:t>CEL PROJEKTU</a:t>
             </a:r>
-            <a:endParaRPr lang="en-US" sz="850" dirty="0"/>
+            <a:endParaRPr lang="pl-PL" sz="850" noProof="0" dirty="0"/>
           </a:p>
         </p:txBody>
       </p:sp>
@@ -2453,7 +3657,7 @@
         <p:spPr>
           <a:xfrm>
             <a:off x="496119" y="1201043"/>
-            <a:ext cx="5689253" cy="442987"/>
+            <a:ext cx="7232254" cy="442987"/>
           </a:xfrm>
           <a:prstGeom prst="rect">
             <a:avLst/>
@@ -2465,14 +3669,13 @@
           <a:bodyPr wrap="none" lIns="0" tIns="0" rIns="0" bIns="0" rtlCol="0" anchor="t"/>
           <a:lstStyle/>
           <a:p>
-            <a:pPr marL="0" indent="0" algn="l">
+            <a:pPr>
               <a:lnSpc>
                 <a:spcPts val="3450"/>
               </a:lnSpc>
-              <a:buNone/>
             </a:pPr>
             <a:r>
-              <a:rPr lang="en-US" sz="2750" dirty="0">
+              <a:rPr lang="pl-PL" sz="2750" noProof="0" dirty="0">
                 <a:solidFill>
                   <a:srgbClr val="201B18"/>
                 </a:solidFill>
@@ -2480,9 +3683,9 @@
                 <a:ea typeface="Platypi Medium" pitchFamily="34" charset="-122"/>
                 <a:cs typeface="Platypi Medium" pitchFamily="34" charset="-120"/>
               </a:rPr>
-              <a:t>Co realizuje AntyDezinformator?</a:t>
-            </a:r>
-            <a:endParaRPr lang="en-US" sz="2750" dirty="0"/>
+              <a:t>Co realizuje System detekcji manipulacji?</a:t>
+            </a:r>
+            <a:endParaRPr lang="pl-PL" sz="2750" noProof="0" dirty="0"/>
           </a:p>
         </p:txBody>
       </p:sp>
@@ -2512,6 +3715,13 @@
             <a:prstDash val="solid"/>
           </a:ln>
         </p:spPr>
+        <p:txBody>
+          <a:bodyPr/>
+          <a:lstStyle/>
+          <a:p>
+            <a:endParaRPr lang="pl-PL" noProof="0" dirty="0"/>
+          </a:p>
+        </p:txBody>
       </p:sp>
       <p:sp>
         <p:nvSpPr>
@@ -2532,6 +3742,13 @@
           </a:solidFill>
           <a:ln/>
         </p:spPr>
+        <p:txBody>
+          <a:bodyPr/>
+          <a:lstStyle/>
+          <a:p>
+            <a:endParaRPr lang="pl-PL" noProof="0" dirty="0"/>
+          </a:p>
+        </p:txBody>
       </p:sp>
       <p:sp>
         <p:nvSpPr>
@@ -2561,7 +3778,7 @@
               <a:buNone/>
             </a:pPr>
             <a:r>
-              <a:rPr lang="en-US" sz="1650" dirty="0">
+              <a:rPr lang="pl-PL" sz="1650" noProof="0" dirty="0">
                 <a:solidFill>
                   <a:srgbClr val="504C49"/>
                 </a:solidFill>
@@ -2571,7 +3788,7 @@
               </a:rPr>
               <a:t>1</a:t>
             </a:r>
-            <a:endParaRPr lang="en-US" sz="1650" dirty="0"/>
+            <a:endParaRPr lang="pl-PL" sz="1650" noProof="0" dirty="0"/>
           </a:p>
         </p:txBody>
       </p:sp>
@@ -2603,7 +3820,7 @@
               <a:buNone/>
             </a:pPr>
             <a:r>
-              <a:rPr lang="en-US" sz="1350" dirty="0">
+              <a:rPr lang="pl-PL" sz="1350" noProof="0" dirty="0">
                 <a:solidFill>
                   <a:srgbClr val="504C49"/>
                 </a:solidFill>
@@ -2613,7 +3830,7 @@
               </a:rPr>
               <a:t>Detekcja technik manipulacji</a:t>
             </a:r>
-            <a:endParaRPr lang="en-US" sz="1350" dirty="0"/>
+            <a:endParaRPr lang="pl-PL" sz="1350" noProof="0" dirty="0"/>
           </a:p>
         </p:txBody>
       </p:sp>
@@ -2644,7 +3861,7 @@
               </a:lnSpc>
             </a:pPr>
             <a:r>
-              <a:rPr lang="pl-PL" sz="1100" dirty="0">
+              <a:rPr lang="pl-PL" sz="1100" noProof="0" dirty="0">
                 <a:solidFill>
                   <a:srgbClr val="504C49"/>
                 </a:solidFill>
@@ -2655,7 +3872,7 @@
               <a:t>Automatyczna identyfikacja </a:t>
             </a:r>
             <a:r>
-              <a:rPr lang="pl-PL" sz="1100" b="1" dirty="0">
+              <a:rPr lang="pl-PL" sz="1100" b="1" noProof="0" dirty="0">
                 <a:solidFill>
                   <a:srgbClr val="504C49"/>
                 </a:solidFill>
@@ -2666,7 +3883,7 @@
               <a:t>11 technik dezinformacji</a:t>
             </a:r>
             <a:r>
-              <a:rPr lang="pl-PL" sz="1100" dirty="0">
+              <a:rPr lang="pl-PL" sz="1100" noProof="0" dirty="0">
                 <a:solidFill>
                   <a:srgbClr val="504C49"/>
                 </a:solidFill>
@@ -2676,7 +3893,7 @@
               </a:rPr>
               <a:t> w polskojęzycznych tekstach — od manipulowania emocjami po wyolbrzymianie faktów</a:t>
             </a:r>
-            <a:endParaRPr lang="en-US" sz="1100" dirty="0"/>
+            <a:endParaRPr lang="pl-PL" sz="1100" noProof="0" dirty="0"/>
           </a:p>
         </p:txBody>
       </p:sp>
@@ -2706,6 +3923,13 @@
             <a:prstDash val="solid"/>
           </a:ln>
         </p:spPr>
+        <p:txBody>
+          <a:bodyPr/>
+          <a:lstStyle/>
+          <a:p>
+            <a:endParaRPr lang="pl-PL" noProof="0" dirty="0"/>
+          </a:p>
+        </p:txBody>
       </p:sp>
       <p:sp>
         <p:nvSpPr>
@@ -2726,6 +3950,13 @@
           </a:solidFill>
           <a:ln/>
         </p:spPr>
+        <p:txBody>
+          <a:bodyPr/>
+          <a:lstStyle/>
+          <a:p>
+            <a:endParaRPr lang="pl-PL" noProof="0" dirty="0"/>
+          </a:p>
+        </p:txBody>
       </p:sp>
       <p:sp>
         <p:nvSpPr>
@@ -2755,7 +3986,7 @@
               <a:buNone/>
             </a:pPr>
             <a:r>
-              <a:rPr lang="en-US" sz="1650" dirty="0">
+              <a:rPr lang="pl-PL" sz="1650" noProof="0" dirty="0">
                 <a:solidFill>
                   <a:srgbClr val="504C49"/>
                 </a:solidFill>
@@ -2765,7 +3996,7 @@
               </a:rPr>
               <a:t>2</a:t>
             </a:r>
-            <a:endParaRPr lang="en-US" sz="1650" dirty="0"/>
+            <a:endParaRPr lang="pl-PL" sz="1650" noProof="0" dirty="0"/>
           </a:p>
         </p:txBody>
       </p:sp>
@@ -2797,7 +4028,7 @@
               <a:buNone/>
             </a:pPr>
             <a:r>
-              <a:rPr lang="en-US" sz="1350" dirty="0">
+              <a:rPr lang="pl-PL" sz="1350" noProof="0" dirty="0">
                 <a:solidFill>
                   <a:srgbClr val="504C49"/>
                 </a:solidFill>
@@ -2807,7 +4038,7 @@
               </a:rPr>
               <a:t>Wyjaśnialne uzasadnienia</a:t>
             </a:r>
-            <a:endParaRPr lang="en-US" sz="1350" dirty="0"/>
+            <a:endParaRPr lang="pl-PL" sz="1350" noProof="0" dirty="0"/>
           </a:p>
         </p:txBody>
       </p:sp>
@@ -2839,7 +4070,7 @@
               <a:buNone/>
             </a:pPr>
             <a:r>
-              <a:rPr lang="en-US" sz="1100" dirty="0">
+              <a:rPr lang="pl-PL" sz="1100" noProof="0" dirty="0">
                 <a:solidFill>
                   <a:srgbClr val="504C49"/>
                 </a:solidFill>
@@ -2850,7 +4081,7 @@
               <a:t>System generuje nie tylko etykietę klasyfikacyjną, lecz także </a:t>
             </a:r>
             <a:r>
-              <a:rPr lang="en-US" sz="1100" b="1" dirty="0">
+              <a:rPr lang="pl-PL" sz="1100" b="1" noProof="0" dirty="0">
                 <a:solidFill>
                   <a:srgbClr val="504C49"/>
                 </a:solidFill>
@@ -2861,7 +4092,7 @@
               <a:t>czytelne uzasadnienie</a:t>
             </a:r>
             <a:r>
-              <a:rPr lang="en-US" sz="1100" dirty="0">
+              <a:rPr lang="pl-PL" sz="1100" noProof="0" dirty="0">
                 <a:solidFill>
                   <a:srgbClr val="504C49"/>
                 </a:solidFill>
@@ -2871,7 +4102,7 @@
               </a:rPr>
               <a:t> decyzji zrozumiałe dla analityka.</a:t>
             </a:r>
-            <a:endParaRPr lang="en-US" sz="1100" dirty="0"/>
+            <a:endParaRPr lang="pl-PL" sz="1100" noProof="0" dirty="0"/>
           </a:p>
         </p:txBody>
       </p:sp>
@@ -2901,6 +4132,13 @@
             <a:prstDash val="solid"/>
           </a:ln>
         </p:spPr>
+        <p:txBody>
+          <a:bodyPr/>
+          <a:lstStyle/>
+          <a:p>
+            <a:endParaRPr lang="pl-PL" noProof="0" dirty="0"/>
+          </a:p>
+        </p:txBody>
       </p:sp>
       <p:sp>
         <p:nvSpPr>
@@ -2921,6 +4159,13 @@
           </a:solidFill>
           <a:ln/>
         </p:spPr>
+        <p:txBody>
+          <a:bodyPr/>
+          <a:lstStyle/>
+          <a:p>
+            <a:endParaRPr lang="pl-PL" noProof="0" dirty="0"/>
+          </a:p>
+        </p:txBody>
       </p:sp>
       <p:sp>
         <p:nvSpPr>
@@ -2950,7 +4195,7 @@
               <a:buNone/>
             </a:pPr>
             <a:r>
-              <a:rPr lang="en-US" sz="1650" dirty="0">
+              <a:rPr lang="pl-PL" sz="1650" noProof="0" dirty="0">
                 <a:solidFill>
                   <a:srgbClr val="504C49"/>
                 </a:solidFill>
@@ -2960,7 +4205,7 @@
               </a:rPr>
               <a:t>3</a:t>
             </a:r>
-            <a:endParaRPr lang="en-US" sz="1650" dirty="0"/>
+            <a:endParaRPr lang="pl-PL" sz="1650" noProof="0" dirty="0"/>
           </a:p>
         </p:txBody>
       </p:sp>
@@ -2985,14 +4230,13 @@
           <a:bodyPr wrap="none" lIns="0" tIns="0" rIns="0" bIns="0" rtlCol="0" anchor="t"/>
           <a:lstStyle/>
           <a:p>
-            <a:pPr marL="0" indent="0" algn="l">
+            <a:pPr>
               <a:lnSpc>
                 <a:spcPts val="1700"/>
               </a:lnSpc>
-              <a:buNone/>
             </a:pPr>
             <a:r>
-              <a:rPr lang="en-US" sz="1350" dirty="0">
+              <a:rPr lang="pl-PL" sz="1350" noProof="0" dirty="0">
                 <a:solidFill>
                   <a:srgbClr val="504C49"/>
                 </a:solidFill>
@@ -3000,9 +4244,9 @@
                 <a:ea typeface="Platypi Medium" pitchFamily="34" charset="-122"/>
                 <a:cs typeface="Platypi Medium" pitchFamily="34" charset="-120"/>
               </a:rPr>
-              <a:t>Pełna pętla MLOps</a:t>
-            </a:r>
-            <a:endParaRPr lang="en-US" sz="1350" dirty="0"/>
+              <a:t>Możliwość douczania</a:t>
+            </a:r>
+            <a:endParaRPr lang="pl-PL" sz="1350" noProof="0" dirty="0"/>
           </a:p>
         </p:txBody>
       </p:sp>
@@ -3027,14 +4271,13 @@
           <a:bodyPr wrap="square" lIns="0" tIns="0" rIns="0" bIns="0" rtlCol="0" anchor="t"/>
           <a:lstStyle/>
           <a:p>
-            <a:pPr marL="0" indent="0" algn="l">
+            <a:pPr>
               <a:lnSpc>
                 <a:spcPts val="1750"/>
               </a:lnSpc>
-              <a:buNone/>
             </a:pPr>
             <a:r>
-              <a:rPr lang="en-US" sz="1100" dirty="0">
+              <a:rPr lang="pl-PL" sz="1100" noProof="0" dirty="0">
                 <a:solidFill>
                   <a:srgbClr val="504C49"/>
                 </a:solidFill>
@@ -3042,10 +4285,10 @@
                 <a:ea typeface="Source Serif 4" pitchFamily="34" charset="-122"/>
                 <a:cs typeface="Source Serif 4" pitchFamily="34" charset="-120"/>
               </a:rPr>
-              <a:t>Zintegrowany cykl: </a:t>
-            </a:r>
-            <a:r>
-              <a:rPr lang="en-US" sz="1100" b="1" dirty="0">
+              <a:t>System może być </a:t>
+            </a:r>
+            <a:r>
+              <a:rPr lang="pl-PL" sz="1100" b="1" noProof="0" dirty="0">
                 <a:solidFill>
                   <a:srgbClr val="504C49"/>
                 </a:solidFill>
@@ -3053,10 +4296,10 @@
                 <a:ea typeface="Source Serif 4" pitchFamily="34" charset="-122"/>
                 <a:cs typeface="Source Serif 4" pitchFamily="34" charset="-120"/>
               </a:rPr>
-              <a:t>trening → douczanie → ewaluacja → wdrożenie (HITL) </a:t>
-            </a:r>
-            <a:r>
-              <a:rPr lang="en-US" sz="1100" dirty="0">
+              <a:t>rozszerzany o nowe przykłady</a:t>
+            </a:r>
+            <a:r>
+              <a:rPr lang="pl-PL" sz="1100" noProof="0" dirty="0">
                 <a:solidFill>
                   <a:srgbClr val="504C49"/>
                 </a:solidFill>
@@ -3064,9 +4307,9 @@
                 <a:ea typeface="Source Serif 4" pitchFamily="34" charset="-122"/>
                 <a:cs typeface="Source Serif 4" pitchFamily="34" charset="-120"/>
               </a:rPr>
-              <a:t>z kontrolą operatora na etapie decyzji o wdrożeniu.</a:t>
-            </a:r>
-            <a:endParaRPr lang="en-US" sz="1100" dirty="0"/>
+              <a:t> i ponownie dostrajany, gdy pojawiają się nowe typy manipulacji.</a:t>
+            </a:r>
+            <a:endParaRPr lang="pl-PL" sz="1100" noProof="0" dirty="0"/>
           </a:p>
         </p:txBody>
       </p:sp>
@@ -3078,9 +4321,9 @@
 </p:sld>
 </file>
 
-<file path=ppt/slides/slide3.xml><?xml version="1.0" encoding="utf-8"?>
+<file path=ppt/slides/slide4.xml><?xml version="1.0" encoding="utf-8"?>
 <p:sld xmlns:a="http://schemas.openxmlformats.org/drawingml/2006/main" xmlns:r="http://schemas.openxmlformats.org/officeDocument/2006/relationships" xmlns:p="http://schemas.openxmlformats.org/presentationml/2006/main" showMasterSp="0">
-  <p:cSld name="Slide 3">
+  <p:cSld name="Slide 5">
     <p:bg>
       <p:bgPr>
         <a:solidFill>
@@ -3111,12 +4354,12 @@
         </p:nvSpPr>
         <p:spPr>
           <a:xfrm>
-            <a:off x="496119" y="420291"/>
-            <a:ext cx="797198" cy="241176"/>
+            <a:off x="496119" y="436696"/>
+            <a:ext cx="1084734" cy="275927"/>
           </a:xfrm>
           <a:prstGeom prst="roundRect">
             <a:avLst>
-              <a:gd name="adj" fmla="val 6348"/>
+              <a:gd name="adj" fmla="val 6165"/>
             </a:avLst>
           </a:prstGeom>
           <a:noFill/>
@@ -3136,8 +4379,8 @@
         </p:nvSpPr>
         <p:spPr>
           <a:xfrm>
-            <a:off x="577379" y="463302"/>
-            <a:ext cx="634678" cy="155153"/>
+            <a:off x="585936" y="483949"/>
+            <a:ext cx="905098" cy="181421"/>
           </a:xfrm>
           <a:prstGeom prst="rect">
             <a:avLst/>
@@ -3151,12 +4394,12 @@
           <a:p>
             <a:pPr marL="0" indent="0" algn="l">
               <a:lnSpc>
-                <a:spcPts val="1200"/>
+                <a:spcPts val="1400"/>
               </a:lnSpc>
               <a:buNone/>
             </a:pPr>
             <a:r>
-              <a:rPr lang="en-US" sz="800" dirty="0">
+              <a:rPr lang="en-US" sz="850" dirty="0">
                 <a:solidFill>
                   <a:srgbClr val="3E2513"/>
                 </a:solidFill>
@@ -3164,9 +4407,9 @@
                 <a:ea typeface="Source Serif 4" pitchFamily="34" charset="-122"/>
                 <a:cs typeface="Source Serif 4" pitchFamily="34" charset="-120"/>
               </a:rPr>
-              <a:t>MOTYWACJA</a:t>
-            </a:r>
-            <a:endParaRPr lang="en-US" sz="800" dirty="0"/>
+              <a:t>ARCHITEKTURA</a:t>
+            </a:r>
+            <a:endParaRPr lang="en-US" sz="850" dirty="0"/>
           </a:p>
         </p:txBody>
       </p:sp>
@@ -3178,8 +4421,8 @@
         </p:nvSpPr>
         <p:spPr>
           <a:xfrm>
-            <a:off x="496119" y="707380"/>
-            <a:ext cx="7370713" cy="398711"/>
+            <a:off x="496119" y="769327"/>
+            <a:ext cx="3793480" cy="442987"/>
           </a:xfrm>
           <a:prstGeom prst="rect">
             <a:avLst/>
@@ -3193,12 +4436,12 @@
           <a:p>
             <a:pPr marL="0" indent="0" algn="l">
               <a:lnSpc>
-                <a:spcPts val="3100"/>
+                <a:spcPts val="3450"/>
               </a:lnSpc>
               <a:buNone/>
             </a:pPr>
             <a:r>
-              <a:rPr lang="en-US" sz="2500" dirty="0">
+              <a:rPr lang="en-US" sz="2750" dirty="0">
                 <a:solidFill>
                   <a:srgbClr val="201B18"/>
                 </a:solidFill>
@@ -3206,580 +4449,153 @@
                 <a:ea typeface="Platypi Medium" pitchFamily="34" charset="-122"/>
                 <a:cs typeface="Platypi Medium" pitchFamily="34" charset="-120"/>
               </a:rPr>
-              <a:t>Dlaczego istniejące rozwiązania nie wystarczą?</a:t>
-            </a:r>
-            <a:endParaRPr lang="en-US" sz="2500" dirty="0"/>
-          </a:p>
-        </p:txBody>
-      </p:sp>
-      <p:sp>
-        <p:nvSpPr>
-          <p:cNvPr id="5" name="Shape 3"/>
-          <p:cNvSpPr/>
-          <p:nvPr/>
-        </p:nvSpPr>
-        <p:spPr>
-          <a:xfrm>
-            <a:off x="496119" y="1407468"/>
-            <a:ext cx="4343400" cy="985614"/>
-          </a:xfrm>
-          <a:prstGeom prst="roundRect">
-            <a:avLst>
-              <a:gd name="adj" fmla="val 6958"/>
-            </a:avLst>
-          </a:prstGeom>
-          <a:solidFill>
-            <a:srgbClr val="FFFFFF"/>
-          </a:solidFill>
-          <a:ln w="14288">
-            <a:solidFill>
-              <a:srgbClr val="D8D4D4"/>
-            </a:solidFill>
-            <a:prstDash val="solid"/>
-          </a:ln>
-        </p:spPr>
-      </p:sp>
-      <p:sp>
-        <p:nvSpPr>
-          <p:cNvPr id="6" name="Shape 4"/>
-          <p:cNvSpPr/>
-          <p:nvPr/>
-        </p:nvSpPr>
-        <p:spPr>
-          <a:xfrm>
-            <a:off x="481831" y="1407468"/>
-            <a:ext cx="57150" cy="985614"/>
-          </a:xfrm>
-          <a:prstGeom prst="roundRect">
-            <a:avLst>
-              <a:gd name="adj" fmla="val 33488"/>
-            </a:avLst>
-          </a:prstGeom>
-          <a:solidFill>
-            <a:srgbClr val="3E2513"/>
-          </a:solidFill>
-          <a:ln/>
-        </p:spPr>
-      </p:sp>
-      <p:sp>
-        <p:nvSpPr>
-          <p:cNvPr id="7" name="Text 5"/>
-          <p:cNvSpPr/>
-          <p:nvPr/>
-        </p:nvSpPr>
-        <p:spPr>
-          <a:xfrm>
-            <a:off x="680814" y="1549301"/>
-            <a:ext cx="2310929" cy="199281"/>
+              <a:t>Architektura systemu</a:t>
+            </a:r>
+            <a:endParaRPr lang="en-US" sz="2750" dirty="0"/>
+          </a:p>
+        </p:txBody>
+      </p:sp>
+      <p:pic>
+        <p:nvPicPr>
+          <p:cNvPr id="8" name="Picture 7">
+            <a:extLst>
+              <a:ext uri="{FF2B5EF4-FFF2-40B4-BE49-F238E27FC236}">
+                <a16:creationId xmlns:a16="http://schemas.microsoft.com/office/drawing/2014/main" id="{976932B1-4338-D53E-CA7C-AD57AC4DC3C4}"/>
+              </a:ext>
+            </a:extLst>
+          </p:cNvPr>
+          <p:cNvPicPr>
+            <a:picLocks noChangeAspect="1"/>
+          </p:cNvPicPr>
+          <p:nvPr/>
+        </p:nvPicPr>
+        <p:blipFill>
+          <a:blip r:embed="rId3"/>
+          <a:stretch>
+            <a:fillRect/>
+          </a:stretch>
+        </p:blipFill>
+        <p:spPr>
+          <a:xfrm>
+            <a:off x="496118" y="1682088"/>
+            <a:ext cx="7987482" cy="837990"/>
+          </a:xfrm>
+          <a:prstGeom prst="rect">
+            <a:avLst/>
+          </a:prstGeom>
+        </p:spPr>
+      </p:pic>
+      <p:pic>
+        <p:nvPicPr>
+          <p:cNvPr id="10" name="Picture 9">
+            <a:extLst>
+              <a:ext uri="{FF2B5EF4-FFF2-40B4-BE49-F238E27FC236}">
+                <a16:creationId xmlns:a16="http://schemas.microsoft.com/office/drawing/2014/main" id="{7844E114-4260-871F-561B-A18CEC280511}"/>
+              </a:ext>
+            </a:extLst>
+          </p:cNvPr>
+          <p:cNvPicPr>
+            <a:picLocks noChangeAspect="1"/>
+          </p:cNvPicPr>
+          <p:nvPr/>
+        </p:nvPicPr>
+        <p:blipFill>
+          <a:blip r:embed="rId4"/>
+          <a:stretch>
+            <a:fillRect/>
+          </a:stretch>
+        </p:blipFill>
+        <p:spPr>
+          <a:xfrm>
+            <a:off x="496119" y="2945619"/>
+            <a:ext cx="7987482" cy="1382978"/>
+          </a:xfrm>
+          <a:prstGeom prst="rect">
+            <a:avLst/>
+          </a:prstGeom>
+        </p:spPr>
+      </p:pic>
+      <p:sp>
+        <p:nvSpPr>
+          <p:cNvPr id="11" name="TextBox 10">
+            <a:extLst>
+              <a:ext uri="{FF2B5EF4-FFF2-40B4-BE49-F238E27FC236}">
+                <a16:creationId xmlns:a16="http://schemas.microsoft.com/office/drawing/2014/main" id="{5B390040-A997-84FB-F4E2-6AB051980B4C}"/>
+              </a:ext>
+            </a:extLst>
+          </p:cNvPr>
+          <p:cNvSpPr txBox="1"/>
+          <p:nvPr/>
+        </p:nvSpPr>
+        <p:spPr>
+          <a:xfrm>
+            <a:off x="3199092" y="2520078"/>
+            <a:ext cx="2181013" cy="261610"/>
           </a:xfrm>
           <a:prstGeom prst="rect">
             <a:avLst/>
           </a:prstGeom>
           <a:noFill/>
-          <a:ln/>
-        </p:spPr>
-        <p:txBody>
-          <a:bodyPr wrap="none" lIns="0" tIns="0" rIns="0" bIns="0" rtlCol="0" anchor="t"/>
-          <a:lstStyle/>
-          <a:p>
-            <a:pPr marL="0" indent="0" algn="l">
-              <a:lnSpc>
-                <a:spcPts val="1550"/>
-              </a:lnSpc>
-              <a:buNone/>
-            </a:pPr>
-            <a:r>
-              <a:rPr lang="en-US" sz="1250" dirty="0">
-                <a:solidFill>
-                  <a:srgbClr val="504C49"/>
-                </a:solidFill>
-                <a:latin typeface="Platypi Medium" pitchFamily="34" charset="0"/>
-                <a:ea typeface="Platypi Medium" pitchFamily="34" charset="-122"/>
-                <a:cs typeface="Platypi Medium" pitchFamily="34" charset="-120"/>
-              </a:rPr>
-              <a:t>BERT i modele klasyfikacyjne</a:t>
-            </a:r>
-            <a:endParaRPr lang="en-US" sz="1250" dirty="0"/>
-          </a:p>
-        </p:txBody>
-      </p:sp>
-      <p:sp>
-        <p:nvSpPr>
-          <p:cNvPr id="8" name="Text 6"/>
-          <p:cNvSpPr/>
-          <p:nvPr/>
-        </p:nvSpPr>
-        <p:spPr>
-          <a:xfrm>
-            <a:off x="680814" y="1863403"/>
-            <a:ext cx="4016871" cy="387846"/>
-          </a:xfrm>
-          <a:prstGeom prst="rect">
-            <a:avLst/>
-          </a:prstGeom>
-          <a:noFill/>
-          <a:ln/>
-        </p:spPr>
-        <p:txBody>
-          <a:bodyPr wrap="square" lIns="0" tIns="0" rIns="0" bIns="0" rtlCol="0" anchor="t"/>
-          <a:lstStyle/>
-          <a:p>
-            <a:pPr marL="0" indent="0" algn="l">
-              <a:lnSpc>
-                <a:spcPts val="1500"/>
-              </a:lnSpc>
-              <a:buNone/>
-            </a:pPr>
-            <a:r>
-              <a:rPr lang="en-US" sz="1000" dirty="0">
+        </p:spPr>
+        <p:txBody>
+          <a:bodyPr wrap="square" rtlCol="0">
+            <a:spAutoFit/>
+          </a:bodyPr>
+          <a:lstStyle/>
+          <a:p>
+            <a:pPr algn="ctr"/>
+            <a:r>
+              <a:rPr lang="pl-PL" sz="1100" dirty="0">
                 <a:solidFill>
                   <a:srgbClr val="504C49"/>
                 </a:solidFill>
                 <a:latin typeface="Source Serif 4" pitchFamily="34" charset="0"/>
                 <a:ea typeface="Source Serif 4" pitchFamily="34" charset="-122"/>
-                <a:cs typeface="Source Serif 4" pitchFamily="34" charset="-120"/>
-              </a:rPr>
-              <a:t>Zwracają wyłącznie </a:t>
-            </a:r>
-            <a:r>
-              <a:rPr lang="en-US" sz="1000" b="1" dirty="0">
+              </a:rPr>
+              <a:t>Tryb 1: analiza tekstu</a:t>
+            </a:r>
+          </a:p>
+        </p:txBody>
+      </p:sp>
+      <p:sp>
+        <p:nvSpPr>
+          <p:cNvPr id="12" name="TextBox 11">
+            <a:extLst>
+              <a:ext uri="{FF2B5EF4-FFF2-40B4-BE49-F238E27FC236}">
+                <a16:creationId xmlns:a16="http://schemas.microsoft.com/office/drawing/2014/main" id="{F12CC224-CDA7-05C3-AC98-88BB7615822F}"/>
+              </a:ext>
+            </a:extLst>
+          </p:cNvPr>
+          <p:cNvSpPr txBox="1"/>
+          <p:nvPr/>
+        </p:nvSpPr>
+        <p:spPr>
+          <a:xfrm>
+            <a:off x="3199091" y="4328597"/>
+            <a:ext cx="2181013" cy="261610"/>
+          </a:xfrm>
+          <a:prstGeom prst="rect">
+            <a:avLst/>
+          </a:prstGeom>
+          <a:noFill/>
+        </p:spPr>
+        <p:txBody>
+          <a:bodyPr wrap="square" rtlCol="0">
+            <a:spAutoFit/>
+          </a:bodyPr>
+          <a:lstStyle/>
+          <a:p>
+            <a:pPr algn="ctr"/>
+            <a:r>
+              <a:rPr lang="pl-PL" sz="1100" dirty="0">
                 <a:solidFill>
                   <a:srgbClr val="504C49"/>
                 </a:solidFill>
                 <a:latin typeface="Source Serif 4" pitchFamily="34" charset="0"/>
                 <a:ea typeface="Source Serif 4" pitchFamily="34" charset="-122"/>
-                <a:cs typeface="Source Serif 4" pitchFamily="34" charset="-120"/>
-              </a:rPr>
-              <a:t>wynik liczbowy</a:t>
-            </a:r>
-            <a:r>
-              <a:rPr lang="en-US" sz="1000" dirty="0">
-                <a:solidFill>
-                  <a:srgbClr val="504C49"/>
-                </a:solidFill>
-                <a:latin typeface="Source Serif 4" pitchFamily="34" charset="0"/>
-                <a:ea typeface="Source Serif 4" pitchFamily="34" charset="-122"/>
-                <a:cs typeface="Source Serif 4" pitchFamily="34" charset="-120"/>
-              </a:rPr>
-              <a:t> — brak jakiegokolwiek wyjaśnienia podjętej decyzji.</a:t>
-            </a:r>
-            <a:endParaRPr lang="en-US" sz="1000" dirty="0"/>
-          </a:p>
-        </p:txBody>
-      </p:sp>
-      <p:sp>
-        <p:nvSpPr>
-          <p:cNvPr id="9" name="Shape 7"/>
-          <p:cNvSpPr/>
-          <p:nvPr/>
-        </p:nvSpPr>
-        <p:spPr>
-          <a:xfrm>
-            <a:off x="496119" y="2507903"/>
-            <a:ext cx="4343400" cy="985614"/>
-          </a:xfrm>
-          <a:prstGeom prst="roundRect">
-            <a:avLst>
-              <a:gd name="adj" fmla="val 6958"/>
-            </a:avLst>
-          </a:prstGeom>
-          <a:solidFill>
-            <a:srgbClr val="FFFFFF"/>
-          </a:solidFill>
-          <a:ln w="14288">
-            <a:solidFill>
-              <a:srgbClr val="D8D4D4"/>
-            </a:solidFill>
-            <a:prstDash val="solid"/>
-          </a:ln>
-        </p:spPr>
-      </p:sp>
-      <p:sp>
-        <p:nvSpPr>
-          <p:cNvPr id="10" name="Shape 8"/>
-          <p:cNvSpPr/>
-          <p:nvPr/>
-        </p:nvSpPr>
-        <p:spPr>
-          <a:xfrm>
-            <a:off x="481831" y="2507903"/>
-            <a:ext cx="57150" cy="985614"/>
-          </a:xfrm>
-          <a:prstGeom prst="roundRect">
-            <a:avLst>
-              <a:gd name="adj" fmla="val 33488"/>
-            </a:avLst>
-          </a:prstGeom>
-          <a:solidFill>
-            <a:srgbClr val="3E2513"/>
-          </a:solidFill>
-          <a:ln/>
-        </p:spPr>
-      </p:sp>
-      <p:sp>
-        <p:nvSpPr>
-          <p:cNvPr id="11" name="Text 9"/>
-          <p:cNvSpPr/>
-          <p:nvPr/>
-        </p:nvSpPr>
-        <p:spPr>
-          <a:xfrm>
-            <a:off x="680814" y="2649736"/>
-            <a:ext cx="2068041" cy="199281"/>
-          </a:xfrm>
-          <a:prstGeom prst="rect">
-            <a:avLst/>
-          </a:prstGeom>
-          <a:noFill/>
-          <a:ln/>
-        </p:spPr>
-        <p:txBody>
-          <a:bodyPr wrap="none" lIns="0" tIns="0" rIns="0" bIns="0" rtlCol="0" anchor="t"/>
-          <a:lstStyle/>
-          <a:p>
-            <a:pPr marL="0" indent="0" algn="l">
-              <a:lnSpc>
-                <a:spcPts val="1550"/>
-              </a:lnSpc>
-              <a:buNone/>
-            </a:pPr>
-            <a:r>
-              <a:rPr lang="en-US" sz="1250" dirty="0">
-                <a:solidFill>
-                  <a:srgbClr val="504C49"/>
-                </a:solidFill>
-                <a:latin typeface="Platypi Medium" pitchFamily="34" charset="0"/>
-                <a:ea typeface="Platypi Medium" pitchFamily="34" charset="-122"/>
-                <a:cs typeface="Platypi Medium" pitchFamily="34" charset="-120"/>
-              </a:rPr>
-              <a:t>GPT-4 i modele chmurowe</a:t>
-            </a:r>
-            <a:endParaRPr lang="en-US" sz="1250" dirty="0"/>
-          </a:p>
-        </p:txBody>
-      </p:sp>
-      <p:sp>
-        <p:nvSpPr>
-          <p:cNvPr id="12" name="Text 10"/>
-          <p:cNvSpPr/>
-          <p:nvPr/>
-        </p:nvSpPr>
-        <p:spPr>
-          <a:xfrm>
-            <a:off x="680814" y="2963838"/>
-            <a:ext cx="4016871" cy="387846"/>
-          </a:xfrm>
-          <a:prstGeom prst="rect">
-            <a:avLst/>
-          </a:prstGeom>
-          <a:noFill/>
-          <a:ln/>
-        </p:spPr>
-        <p:txBody>
-          <a:bodyPr wrap="square" lIns="0" tIns="0" rIns="0" bIns="0" rtlCol="0" anchor="t"/>
-          <a:lstStyle/>
-          <a:p>
-            <a:pPr marL="0" indent="0" algn="l">
-              <a:lnSpc>
-                <a:spcPts val="1500"/>
-              </a:lnSpc>
-              <a:buNone/>
-            </a:pPr>
-            <a:r>
-              <a:rPr lang="en-US" sz="1000" dirty="0">
-                <a:solidFill>
-                  <a:srgbClr val="504C49"/>
-                </a:solidFill>
-                <a:latin typeface="Source Serif 4" pitchFamily="34" charset="0"/>
-                <a:ea typeface="Source Serif 4" pitchFamily="34" charset="-122"/>
-                <a:cs typeface="Source Serif 4" pitchFamily="34" charset="-120"/>
-              </a:rPr>
-              <a:t>Ograniczenia cenzury treści, </a:t>
-            </a:r>
-            <a:r>
-              <a:rPr lang="en-US" sz="1000" b="1" dirty="0">
-                <a:solidFill>
-                  <a:srgbClr val="504C49"/>
-                </a:solidFill>
-                <a:latin typeface="Source Serif 4" pitchFamily="34" charset="0"/>
-                <a:ea typeface="Source Serif 4" pitchFamily="34" charset="-122"/>
-                <a:cs typeface="Source Serif 4" pitchFamily="34" charset="-120"/>
-              </a:rPr>
-              <a:t>wysokie koszty API</a:t>
-            </a:r>
-            <a:r>
-              <a:rPr lang="en-US" sz="1000" dirty="0">
-                <a:solidFill>
-                  <a:srgbClr val="504C49"/>
-                </a:solidFill>
-                <a:latin typeface="Source Serif 4" pitchFamily="34" charset="0"/>
-                <a:ea typeface="Source Serif 4" pitchFamily="34" charset="-122"/>
-                <a:cs typeface="Source Serif 4" pitchFamily="34" charset="-120"/>
-              </a:rPr>
-              <a:t> oraz ryzyko naruszenia prywatności danych.</a:t>
-            </a:r>
-            <a:endParaRPr lang="en-US" sz="1000" dirty="0"/>
-          </a:p>
-        </p:txBody>
-      </p:sp>
-      <p:sp>
-        <p:nvSpPr>
-          <p:cNvPr id="13" name="Shape 11"/>
-          <p:cNvSpPr/>
-          <p:nvPr/>
-        </p:nvSpPr>
-        <p:spPr>
-          <a:xfrm>
-            <a:off x="496119" y="3608338"/>
-            <a:ext cx="4343400" cy="985614"/>
-          </a:xfrm>
-          <a:prstGeom prst="roundRect">
-            <a:avLst>
-              <a:gd name="adj" fmla="val 6958"/>
-            </a:avLst>
-          </a:prstGeom>
-          <a:solidFill>
-            <a:srgbClr val="FFFFFF"/>
-          </a:solidFill>
-          <a:ln w="14288">
-            <a:solidFill>
-              <a:srgbClr val="D8D4D4"/>
-            </a:solidFill>
-            <a:prstDash val="solid"/>
-          </a:ln>
-        </p:spPr>
-      </p:sp>
-      <p:sp>
-        <p:nvSpPr>
-          <p:cNvPr id="14" name="Shape 12"/>
-          <p:cNvSpPr/>
-          <p:nvPr/>
-        </p:nvSpPr>
-        <p:spPr>
-          <a:xfrm>
-            <a:off x="481831" y="3608338"/>
-            <a:ext cx="57150" cy="985614"/>
-          </a:xfrm>
-          <a:prstGeom prst="roundRect">
-            <a:avLst>
-              <a:gd name="adj" fmla="val 33488"/>
-            </a:avLst>
-          </a:prstGeom>
-          <a:solidFill>
-            <a:srgbClr val="3E2513"/>
-          </a:solidFill>
-          <a:ln/>
-        </p:spPr>
-      </p:sp>
-      <p:sp>
-        <p:nvSpPr>
-          <p:cNvPr id="15" name="Text 13"/>
-          <p:cNvSpPr/>
-          <p:nvPr/>
-        </p:nvSpPr>
-        <p:spPr>
-          <a:xfrm>
-            <a:off x="680814" y="3750171"/>
-            <a:ext cx="1660252" cy="199281"/>
-          </a:xfrm>
-          <a:prstGeom prst="rect">
-            <a:avLst/>
-          </a:prstGeom>
-          <a:noFill/>
-          <a:ln/>
-        </p:spPr>
-        <p:txBody>
-          <a:bodyPr wrap="none" lIns="0" tIns="0" rIns="0" bIns="0" rtlCol="0" anchor="t"/>
-          <a:lstStyle/>
-          <a:p>
-            <a:pPr marL="0" indent="0" algn="l">
-              <a:lnSpc>
-                <a:spcPts val="1550"/>
-              </a:lnSpc>
-              <a:buNone/>
-            </a:pPr>
-            <a:r>
-              <a:rPr lang="en-US" sz="1250" dirty="0">
-                <a:solidFill>
-                  <a:srgbClr val="504C49"/>
-                </a:solidFill>
-                <a:latin typeface="Platypi Medium" pitchFamily="34" charset="0"/>
-                <a:ea typeface="Platypi Medium" pitchFamily="34" charset="-122"/>
-                <a:cs typeface="Platypi Medium" pitchFamily="34" charset="-120"/>
-              </a:rPr>
-              <a:t>Ręczny fact-checking</a:t>
-            </a:r>
-            <a:endParaRPr lang="en-US" sz="1250" dirty="0"/>
-          </a:p>
-        </p:txBody>
-      </p:sp>
-      <p:sp>
-        <p:nvSpPr>
-          <p:cNvPr id="16" name="Text 14"/>
-          <p:cNvSpPr/>
-          <p:nvPr/>
-        </p:nvSpPr>
-        <p:spPr>
-          <a:xfrm>
-            <a:off x="680814" y="4064273"/>
-            <a:ext cx="4016871" cy="387846"/>
-          </a:xfrm>
-          <a:prstGeom prst="rect">
-            <a:avLst/>
-          </a:prstGeom>
-          <a:noFill/>
-          <a:ln/>
-        </p:spPr>
-        <p:txBody>
-          <a:bodyPr wrap="square" lIns="0" tIns="0" rIns="0" bIns="0" rtlCol="0" anchor="t"/>
-          <a:lstStyle/>
-          <a:p>
-            <a:pPr marL="0" indent="0" algn="l">
-              <a:lnSpc>
-                <a:spcPts val="1500"/>
-              </a:lnSpc>
-              <a:buNone/>
-            </a:pPr>
-            <a:r>
-              <a:rPr lang="en-US" sz="1000" dirty="0">
-                <a:solidFill>
-                  <a:srgbClr val="504C49"/>
-                </a:solidFill>
-                <a:latin typeface="Source Serif 4" pitchFamily="34" charset="0"/>
-                <a:ea typeface="Source Serif 4" pitchFamily="34" charset="-122"/>
-                <a:cs typeface="Source Serif 4" pitchFamily="34" charset="-120"/>
-              </a:rPr>
-              <a:t>Weryfikacja jednego artykułu zajmuje </a:t>
-            </a:r>
-            <a:r>
-              <a:rPr lang="en-US" sz="1000" b="1" dirty="0">
-                <a:solidFill>
-                  <a:srgbClr val="504C49"/>
-                </a:solidFill>
-                <a:latin typeface="Source Serif 4" pitchFamily="34" charset="0"/>
-                <a:ea typeface="Source Serif 4" pitchFamily="34" charset="-122"/>
-                <a:cs typeface="Source Serif 4" pitchFamily="34" charset="-120"/>
-              </a:rPr>
-              <a:t>godziny pracy</a:t>
-            </a:r>
-            <a:r>
-              <a:rPr lang="en-US" sz="1000" dirty="0">
-                <a:solidFill>
-                  <a:srgbClr val="504C49"/>
-                </a:solidFill>
-                <a:latin typeface="Source Serif 4" pitchFamily="34" charset="0"/>
-                <a:ea typeface="Source Serif 4" pitchFamily="34" charset="-122"/>
-                <a:cs typeface="Source Serif 4" pitchFamily="34" charset="-120"/>
-              </a:rPr>
-              <a:t> eksperta — metoda całkowicie nieskalo­walna.</a:t>
-            </a:r>
-            <a:endParaRPr lang="en-US" sz="1000" dirty="0"/>
-          </a:p>
-        </p:txBody>
-      </p:sp>
-      <p:sp>
-        <p:nvSpPr>
-          <p:cNvPr id="17" name="Shape 15"/>
-          <p:cNvSpPr/>
-          <p:nvPr/>
-        </p:nvSpPr>
-        <p:spPr>
-          <a:xfrm>
-            <a:off x="5063654" y="1278285"/>
-            <a:ext cx="3680743" cy="3444850"/>
-          </a:xfrm>
-          <a:prstGeom prst="roundRect">
-            <a:avLst>
-              <a:gd name="adj" fmla="val 556"/>
-            </a:avLst>
-          </a:prstGeom>
-          <a:solidFill>
-            <a:srgbClr val="1A3A52"/>
-          </a:solidFill>
-          <a:ln/>
-        </p:spPr>
-      </p:sp>
-      <p:sp>
-        <p:nvSpPr>
-          <p:cNvPr id="18" name="Text 16"/>
-          <p:cNvSpPr/>
-          <p:nvPr/>
-        </p:nvSpPr>
-        <p:spPr>
-          <a:xfrm>
-            <a:off x="5191199" y="1393106"/>
-            <a:ext cx="1615008" cy="199281"/>
-          </a:xfrm>
-          <a:prstGeom prst="rect">
-            <a:avLst/>
-          </a:prstGeom>
-          <a:noFill/>
-          <a:ln/>
-        </p:spPr>
-        <p:txBody>
-          <a:bodyPr wrap="none" lIns="0" tIns="0" rIns="0" bIns="0" rtlCol="0" anchor="t"/>
-          <a:lstStyle/>
-          <a:p>
-            <a:pPr marL="0" indent="0" algn="l">
-              <a:lnSpc>
-                <a:spcPts val="1550"/>
-              </a:lnSpc>
-              <a:buNone/>
-            </a:pPr>
-            <a:r>
-              <a:rPr lang="en-US" sz="1250" dirty="0">
-                <a:solidFill>
-                  <a:srgbClr val="FFFFFF"/>
-                </a:solidFill>
-                <a:latin typeface="Platypi Medium" pitchFamily="34" charset="0"/>
-                <a:ea typeface="Platypi Medium" pitchFamily="34" charset="-122"/>
-                <a:cs typeface="Platypi Medium" pitchFamily="34" charset="-120"/>
-              </a:rPr>
-              <a:t>Luka technologiczna</a:t>
-            </a:r>
-            <a:endParaRPr lang="en-US" sz="1250" dirty="0"/>
-          </a:p>
-        </p:txBody>
-      </p:sp>
-      <p:sp>
-        <p:nvSpPr>
-          <p:cNvPr id="19" name="Text 17"/>
-          <p:cNvSpPr/>
-          <p:nvPr/>
-        </p:nvSpPr>
-        <p:spPr>
-          <a:xfrm>
-            <a:off x="5191199" y="1707207"/>
-            <a:ext cx="3425651" cy="581769"/>
-          </a:xfrm>
-          <a:prstGeom prst="rect">
-            <a:avLst/>
-          </a:prstGeom>
-          <a:noFill/>
-          <a:ln/>
-        </p:spPr>
-        <p:txBody>
-          <a:bodyPr wrap="square" lIns="0" tIns="0" rIns="0" bIns="0" rtlCol="0" anchor="t"/>
-          <a:lstStyle/>
-          <a:p>
-            <a:pPr marL="0" indent="0" algn="l">
-              <a:lnSpc>
-                <a:spcPts val="1500"/>
-              </a:lnSpc>
-              <a:buNone/>
-            </a:pPr>
-            <a:r>
-              <a:rPr lang="en-US" sz="1000" dirty="0">
-                <a:solidFill>
-                  <a:srgbClr val="FFFFFF"/>
-                </a:solidFill>
-                <a:latin typeface="Source Serif 4" pitchFamily="34" charset="0"/>
-                <a:ea typeface="Source Serif 4" pitchFamily="34" charset="-122"/>
-                <a:cs typeface="Source Serif 4" pitchFamily="34" charset="-120"/>
-              </a:rPr>
-              <a:t>Żadne z dostępnych rozwiązań nie łączy jednocześnie: lokalnego wdrożenia, wyjaśnialności oraz adaptacji do nowych danych bez zewnętrznych zależności.</a:t>
-            </a:r>
-            <a:endParaRPr lang="en-US" sz="1000" dirty="0"/>
+              </a:rPr>
+              <a:t>Tryb 2: douczanie eksperckie</a:t>
+            </a:r>
           </a:p>
         </p:txBody>
       </p:sp>
@@ -3791,7 +4607,253 @@
 </p:sld>
 </file>
 
-<file path=ppt/slides/slide4.xml><?xml version="1.0" encoding="utf-8"?>
+<file path=ppt/slides/slide5.xml><?xml version="1.0" encoding="utf-8"?>
+<p:sld xmlns:a="http://schemas.openxmlformats.org/drawingml/2006/main" xmlns:r="http://schemas.openxmlformats.org/officeDocument/2006/relationships" xmlns:p="http://schemas.openxmlformats.org/presentationml/2006/main">
+  <p:cSld>
+    <p:spTree>
+      <p:nvGrpSpPr>
+        <p:cNvPr id="1" name=""/>
+        <p:cNvGrpSpPr/>
+        <p:nvPr/>
+      </p:nvGrpSpPr>
+      <p:grpSpPr>
+        <a:xfrm>
+          <a:off x="0" y="0"/>
+          <a:ext cx="0" cy="0"/>
+          <a:chOff x="0" y="0"/>
+          <a:chExt cx="0" cy="0"/>
+        </a:xfrm>
+      </p:grpSpPr>
+      <p:sp>
+        <p:nvSpPr>
+          <p:cNvPr id="2" name="Rectangle 1">
+            <a:extLst>
+              <a:ext uri="{FF2B5EF4-FFF2-40B4-BE49-F238E27FC236}">
+                <a16:creationId xmlns:a16="http://schemas.microsoft.com/office/drawing/2014/main" id="{197608F7-29F4-F13F-198F-E84029BE48C6}"/>
+              </a:ext>
+            </a:extLst>
+          </p:cNvPr>
+          <p:cNvSpPr/>
+          <p:nvPr/>
+        </p:nvSpPr>
+        <p:spPr>
+          <a:xfrm>
+            <a:off x="495300" y="231059"/>
+            <a:ext cx="1600200" cy="330200"/>
+          </a:xfrm>
+          <a:prstGeom prst="rect">
+            <a:avLst/>
+          </a:prstGeom>
+          <a:solidFill>
+            <a:srgbClr val="F3E7DF"/>
+          </a:solidFill>
+          <a:ln w="12700" cap="flat" cmpd="sng" algn="ctr">
+            <a:noFill/>
+            <a:prstDash val="solid"/>
+            <a:miter lim="800000"/>
+          </a:ln>
+          <a:effectLst/>
+          <a:extLst>
+            <a:ext uri="{91240B29-F687-4F45-9708-019B960494DF}">
+              <a14:hiddenLine xmlns:a14="http://schemas.microsoft.com/office/drawing/2010/main" w="12700" cap="flat" cmpd="sng" algn="ctr">
+                <a:solidFill>
+                  <a:schemeClr val="accent1">
+                    <a:shade val="15000"/>
+                  </a:schemeClr>
+                </a:solidFill>
+                <a:prstDash val="solid"/>
+                <a:miter lim="800000"/>
+              </a14:hiddenLine>
+            </a:ext>
+          </a:extLst>
+        </p:spPr>
+        <p:style>
+          <a:lnRef idx="2">
+            <a:schemeClr val="accent1">
+              <a:shade val="15000"/>
+            </a:schemeClr>
+          </a:lnRef>
+          <a:fillRef idx="1">
+            <a:schemeClr val="accent1"/>
+          </a:fillRef>
+          <a:effectRef idx="0">
+            <a:schemeClr val="accent1"/>
+          </a:effectRef>
+          <a:fontRef idx="minor">
+            <a:schemeClr val="lt1"/>
+          </a:fontRef>
+        </p:style>
+        <p:txBody>
+          <a:bodyPr rtlCol="0" anchor="ctr"/>
+          <a:lstStyle/>
+          <a:p>
+            <a:pPr algn="ctr"/>
+            <a:r>
+              <a:rPr lang="pl-PL" sz="900" noProof="0" dirty="0">
+                <a:solidFill>
+                  <a:srgbClr val="3A2A22"/>
+                </a:solidFill>
+                <a:latin typeface="Georgia" panose="02040502050405020303" pitchFamily="18" charset="0"/>
+              </a:rPr>
+              <a:t>PRZYKŁAD DZIAŁANIA</a:t>
+            </a:r>
+          </a:p>
+        </p:txBody>
+      </p:sp>
+      <p:sp>
+        <p:nvSpPr>
+          <p:cNvPr id="3" name="TextBox 2">
+            <a:extLst>
+              <a:ext uri="{FF2B5EF4-FFF2-40B4-BE49-F238E27FC236}">
+                <a16:creationId xmlns:a16="http://schemas.microsoft.com/office/drawing/2014/main" id="{031A1DDF-722C-A2C1-DAF4-005E3FAF1D99}"/>
+              </a:ext>
+            </a:extLst>
+          </p:cNvPr>
+          <p:cNvSpPr txBox="1"/>
+          <p:nvPr/>
+        </p:nvSpPr>
+        <p:spPr>
+          <a:xfrm>
+            <a:off x="495300" y="620816"/>
+            <a:ext cx="8255000" cy="569387"/>
+          </a:xfrm>
+          <a:prstGeom prst="rect">
+            <a:avLst/>
+          </a:prstGeom>
+          <a:noFill/>
+        </p:spPr>
+        <p:txBody>
+          <a:bodyPr vert="horz" rtlCol="0">
+            <a:spAutoFit/>
+          </a:bodyPr>
+          <a:lstStyle/>
+          <a:p>
+            <a:r>
+              <a:rPr lang="pl-PL" sz="3100" b="1" noProof="0" dirty="0">
+                <a:solidFill>
+                  <a:srgbClr val="201B19"/>
+                </a:solidFill>
+                <a:latin typeface="Georgia" panose="02040502050405020303" pitchFamily="18" charset="0"/>
+              </a:rPr>
+              <a:t>Przykład działania systemu</a:t>
+            </a:r>
+          </a:p>
+        </p:txBody>
+      </p:sp>
+      <p:sp>
+        <p:nvSpPr>
+          <p:cNvPr id="4" name="TextBox 3">
+            <a:extLst>
+              <a:ext uri="{FF2B5EF4-FFF2-40B4-BE49-F238E27FC236}">
+                <a16:creationId xmlns:a16="http://schemas.microsoft.com/office/drawing/2014/main" id="{4046FC2C-9433-9DB7-AC63-D613AD5AAE92}"/>
+              </a:ext>
+            </a:extLst>
+          </p:cNvPr>
+          <p:cNvSpPr txBox="1"/>
+          <p:nvPr/>
+        </p:nvSpPr>
+        <p:spPr>
+          <a:xfrm>
+            <a:off x="520700" y="1190203"/>
+            <a:ext cx="8128000" cy="307777"/>
+          </a:xfrm>
+          <a:prstGeom prst="rect">
+            <a:avLst/>
+          </a:prstGeom>
+          <a:noFill/>
+        </p:spPr>
+        <p:txBody>
+          <a:bodyPr vert="horz" rtlCol="0">
+            <a:spAutoFit/>
+          </a:bodyPr>
+          <a:lstStyle/>
+          <a:p>
+            <a:r>
+              <a:rPr lang="pl-PL" sz="1400" noProof="0" dirty="0">
+                <a:solidFill>
+                  <a:srgbClr val="5B5652"/>
+                </a:solidFill>
+                <a:latin typeface="Georgia" panose="02040502050405020303" pitchFamily="18" charset="0"/>
+              </a:rPr>
+              <a:t>Input: fragment artykułu → Output: wykryte techniki manipulacji + uzasadnienie decyzji</a:t>
+            </a:r>
+          </a:p>
+        </p:txBody>
+      </p:sp>
+      <p:pic>
+        <p:nvPicPr>
+          <p:cNvPr id="14" name="Picture 13">
+            <a:extLst>
+              <a:ext uri="{FF2B5EF4-FFF2-40B4-BE49-F238E27FC236}">
+                <a16:creationId xmlns:a16="http://schemas.microsoft.com/office/drawing/2014/main" id="{6A8A00D8-20F4-0841-D3BB-5A2079054790}"/>
+              </a:ext>
+            </a:extLst>
+          </p:cNvPr>
+          <p:cNvPicPr>
+            <a:picLocks noChangeAspect="1"/>
+          </p:cNvPicPr>
+          <p:nvPr/>
+        </p:nvPicPr>
+        <p:blipFill>
+          <a:blip r:embed="rId2"/>
+          <a:stretch>
+            <a:fillRect/>
+          </a:stretch>
+        </p:blipFill>
+        <p:spPr>
+          <a:xfrm>
+            <a:off x="1032968" y="1601747"/>
+            <a:ext cx="7078063" cy="1390844"/>
+          </a:xfrm>
+          <a:prstGeom prst="rect">
+            <a:avLst/>
+          </a:prstGeom>
+        </p:spPr>
+      </p:pic>
+      <p:pic>
+        <p:nvPicPr>
+          <p:cNvPr id="16" name="Picture 15">
+            <a:extLst>
+              <a:ext uri="{FF2B5EF4-FFF2-40B4-BE49-F238E27FC236}">
+                <a16:creationId xmlns:a16="http://schemas.microsoft.com/office/drawing/2014/main" id="{E3396B52-A9D7-1134-8F26-A6B0D5D0A853}"/>
+              </a:ext>
+            </a:extLst>
+          </p:cNvPr>
+          <p:cNvPicPr>
+            <a:picLocks noChangeAspect="1"/>
+          </p:cNvPicPr>
+          <p:nvPr/>
+        </p:nvPicPr>
+        <p:blipFill>
+          <a:blip r:embed="rId3"/>
+          <a:stretch>
+            <a:fillRect/>
+          </a:stretch>
+        </p:blipFill>
+        <p:spPr>
+          <a:xfrm>
+            <a:off x="1754883" y="3096358"/>
+            <a:ext cx="5634234" cy="1878078"/>
+          </a:xfrm>
+          <a:prstGeom prst="rect">
+            <a:avLst/>
+          </a:prstGeom>
+        </p:spPr>
+      </p:pic>
+    </p:spTree>
+    <p:extLst>
+      <p:ext uri="{BB962C8B-B14F-4D97-AF65-F5344CB8AC3E}">
+        <p14:creationId xmlns:p14="http://schemas.microsoft.com/office/powerpoint/2010/main" val="1772502965"/>
+      </p:ext>
+    </p:extLst>
+  </p:cSld>
+  <p:clrMapOvr>
+    <a:masterClrMapping/>
+  </p:clrMapOvr>
+</p:sld>
+</file>
+
+<file path=ppt/slides/slide6.xml><?xml version="1.0" encoding="utf-8"?>
 <p:sld xmlns:a="http://schemas.openxmlformats.org/drawingml/2006/main" xmlns:r="http://schemas.openxmlformats.org/officeDocument/2006/relationships" xmlns:p="http://schemas.openxmlformats.org/presentationml/2006/main" showMasterSp="0">
   <p:cSld name="Slide 4">
     <p:bg>
@@ -4518,310 +5580,7 @@
 </p:sld>
 </file>
 
-<file path=ppt/slides/slide5.xml><?xml version="1.0" encoding="utf-8"?>
-<p:sld xmlns:a="http://schemas.openxmlformats.org/drawingml/2006/main" xmlns:r="http://schemas.openxmlformats.org/officeDocument/2006/relationships" xmlns:p="http://schemas.openxmlformats.org/presentationml/2006/main" showMasterSp="0">
-  <p:cSld name="Slide 5">
-    <p:bg>
-      <p:bgPr>
-        <a:solidFill>
-          <a:schemeClr val="bg1"/>
-        </a:solidFill>
-        <a:effectLst/>
-      </p:bgPr>
-    </p:bg>
-    <p:spTree>
-      <p:nvGrpSpPr>
-        <p:cNvPr id="1" name=""/>
-        <p:cNvGrpSpPr/>
-        <p:nvPr/>
-      </p:nvGrpSpPr>
-      <p:grpSpPr>
-        <a:xfrm>
-          <a:off x="0" y="0"/>
-          <a:ext cx="0" cy="0"/>
-          <a:chOff x="0" y="0"/>
-          <a:chExt cx="0" cy="0"/>
-        </a:xfrm>
-      </p:grpSpPr>
-      <p:sp>
-        <p:nvSpPr>
-          <p:cNvPr id="2" name="Shape 0"/>
-          <p:cNvSpPr/>
-          <p:nvPr/>
-        </p:nvSpPr>
-        <p:spPr>
-          <a:xfrm>
-            <a:off x="496119" y="436696"/>
-            <a:ext cx="1084734" cy="275927"/>
-          </a:xfrm>
-          <a:prstGeom prst="roundRect">
-            <a:avLst>
-              <a:gd name="adj" fmla="val 6165"/>
-            </a:avLst>
-          </a:prstGeom>
-          <a:noFill/>
-          <a:ln w="4763">
-            <a:solidFill>
-              <a:srgbClr val="3E2513"/>
-            </a:solidFill>
-            <a:prstDash val="solid"/>
-          </a:ln>
-        </p:spPr>
-      </p:sp>
-      <p:sp>
-        <p:nvSpPr>
-          <p:cNvPr id="3" name="Text 1"/>
-          <p:cNvSpPr/>
-          <p:nvPr/>
-        </p:nvSpPr>
-        <p:spPr>
-          <a:xfrm>
-            <a:off x="585936" y="483949"/>
-            <a:ext cx="905098" cy="181421"/>
-          </a:xfrm>
-          <a:prstGeom prst="rect">
-            <a:avLst/>
-          </a:prstGeom>
-          <a:noFill/>
-          <a:ln/>
-        </p:spPr>
-        <p:txBody>
-          <a:bodyPr wrap="none" lIns="0" tIns="0" rIns="0" bIns="0" rtlCol="0" anchor="t"/>
-          <a:lstStyle/>
-          <a:p>
-            <a:pPr marL="0" indent="0" algn="l">
-              <a:lnSpc>
-                <a:spcPts val="1400"/>
-              </a:lnSpc>
-              <a:buNone/>
-            </a:pPr>
-            <a:r>
-              <a:rPr lang="en-US" sz="850" dirty="0">
-                <a:solidFill>
-                  <a:srgbClr val="3E2513"/>
-                </a:solidFill>
-                <a:latin typeface="Source Serif 4" pitchFamily="34" charset="0"/>
-                <a:ea typeface="Source Serif 4" pitchFamily="34" charset="-122"/>
-                <a:cs typeface="Source Serif 4" pitchFamily="34" charset="-120"/>
-              </a:rPr>
-              <a:t>ARCHITEKTURA</a:t>
-            </a:r>
-            <a:endParaRPr lang="en-US" sz="850" dirty="0"/>
-          </a:p>
-        </p:txBody>
-      </p:sp>
-      <p:sp>
-        <p:nvSpPr>
-          <p:cNvPr id="4" name="Text 2"/>
-          <p:cNvSpPr/>
-          <p:nvPr/>
-        </p:nvSpPr>
-        <p:spPr>
-          <a:xfrm>
-            <a:off x="496119" y="769327"/>
-            <a:ext cx="3793480" cy="442987"/>
-          </a:xfrm>
-          <a:prstGeom prst="rect">
-            <a:avLst/>
-          </a:prstGeom>
-          <a:noFill/>
-          <a:ln/>
-        </p:spPr>
-        <p:txBody>
-          <a:bodyPr wrap="none" lIns="0" tIns="0" rIns="0" bIns="0" rtlCol="0" anchor="t"/>
-          <a:lstStyle/>
-          <a:p>
-            <a:pPr marL="0" indent="0" algn="l">
-              <a:lnSpc>
-                <a:spcPts val="3450"/>
-              </a:lnSpc>
-              <a:buNone/>
-            </a:pPr>
-            <a:r>
-              <a:rPr lang="en-US" sz="2750" dirty="0">
-                <a:solidFill>
-                  <a:srgbClr val="201B18"/>
-                </a:solidFill>
-                <a:latin typeface="Platypi Medium" pitchFamily="34" charset="0"/>
-                <a:ea typeface="Platypi Medium" pitchFamily="34" charset="-122"/>
-                <a:cs typeface="Platypi Medium" pitchFamily="34" charset="-120"/>
-              </a:rPr>
-              <a:t>Architektura systemu</a:t>
-            </a:r>
-            <a:endParaRPr lang="en-US" sz="2750" dirty="0"/>
-          </a:p>
-        </p:txBody>
-      </p:sp>
-      <p:pic>
-        <p:nvPicPr>
-          <p:cNvPr id="8" name="Picture 7">
-            <a:extLst>
-              <a:ext uri="{FF2B5EF4-FFF2-40B4-BE49-F238E27FC236}">
-                <a16:creationId xmlns:a16="http://schemas.microsoft.com/office/drawing/2014/main" id="{976932B1-4338-D53E-CA7C-AD57AC4DC3C4}"/>
-              </a:ext>
-            </a:extLst>
-          </p:cNvPr>
-          <p:cNvPicPr>
-            <a:picLocks noChangeAspect="1"/>
-          </p:cNvPicPr>
-          <p:nvPr/>
-        </p:nvPicPr>
-        <p:blipFill>
-          <a:blip r:embed="rId3"/>
-          <a:stretch>
-            <a:fillRect/>
-          </a:stretch>
-        </p:blipFill>
-        <p:spPr>
-          <a:xfrm>
-            <a:off x="496118" y="1682088"/>
-            <a:ext cx="7987482" cy="837990"/>
-          </a:xfrm>
-          <a:prstGeom prst="rect">
-            <a:avLst/>
-          </a:prstGeom>
-        </p:spPr>
-      </p:pic>
-      <p:pic>
-        <p:nvPicPr>
-          <p:cNvPr id="10" name="Picture 9">
-            <a:extLst>
-              <a:ext uri="{FF2B5EF4-FFF2-40B4-BE49-F238E27FC236}">
-                <a16:creationId xmlns:a16="http://schemas.microsoft.com/office/drawing/2014/main" id="{7844E114-4260-871F-561B-A18CEC280511}"/>
-              </a:ext>
-            </a:extLst>
-          </p:cNvPr>
-          <p:cNvPicPr>
-            <a:picLocks noChangeAspect="1"/>
-          </p:cNvPicPr>
-          <p:nvPr/>
-        </p:nvPicPr>
-        <p:blipFill>
-          <a:blip r:embed="rId4"/>
-          <a:stretch>
-            <a:fillRect/>
-          </a:stretch>
-        </p:blipFill>
-        <p:spPr>
-          <a:xfrm>
-            <a:off x="496119" y="2945619"/>
-            <a:ext cx="7987482" cy="1382978"/>
-          </a:xfrm>
-          <a:prstGeom prst="rect">
-            <a:avLst/>
-          </a:prstGeom>
-        </p:spPr>
-      </p:pic>
-      <p:sp>
-        <p:nvSpPr>
-          <p:cNvPr id="11" name="TextBox 10">
-            <a:extLst>
-              <a:ext uri="{FF2B5EF4-FFF2-40B4-BE49-F238E27FC236}">
-                <a16:creationId xmlns:a16="http://schemas.microsoft.com/office/drawing/2014/main" id="{5B390040-A997-84FB-F4E2-6AB051980B4C}"/>
-              </a:ext>
-            </a:extLst>
-          </p:cNvPr>
-          <p:cNvSpPr txBox="1"/>
-          <p:nvPr/>
-        </p:nvSpPr>
-        <p:spPr>
-          <a:xfrm>
-            <a:off x="3199092" y="2520078"/>
-            <a:ext cx="2181013" cy="261610"/>
-          </a:xfrm>
-          <a:prstGeom prst="rect">
-            <a:avLst/>
-          </a:prstGeom>
-          <a:noFill/>
-        </p:spPr>
-        <p:txBody>
-          <a:bodyPr wrap="square" rtlCol="0">
-            <a:spAutoFit/>
-          </a:bodyPr>
-          <a:lstStyle/>
-          <a:p>
-            <a:pPr algn="ctr"/>
-            <a:r>
-              <a:rPr lang="pl-PL" sz="1100" dirty="0">
-                <a:solidFill>
-                  <a:srgbClr val="504C49"/>
-                </a:solidFill>
-                <a:latin typeface="Source Serif 4" pitchFamily="34" charset="0"/>
-                <a:ea typeface="Source Serif 4" pitchFamily="34" charset="-122"/>
-              </a:rPr>
-              <a:t>Główny przepływ</a:t>
-            </a:r>
-          </a:p>
-        </p:txBody>
-      </p:sp>
-      <p:sp>
-        <p:nvSpPr>
-          <p:cNvPr id="12" name="TextBox 11">
-            <a:extLst>
-              <a:ext uri="{FF2B5EF4-FFF2-40B4-BE49-F238E27FC236}">
-                <a16:creationId xmlns:a16="http://schemas.microsoft.com/office/drawing/2014/main" id="{F12CC224-CDA7-05C3-AC98-88BB7615822F}"/>
-              </a:ext>
-            </a:extLst>
-          </p:cNvPr>
-          <p:cNvSpPr txBox="1"/>
-          <p:nvPr/>
-        </p:nvSpPr>
-        <p:spPr>
-          <a:xfrm>
-            <a:off x="3199091" y="4328597"/>
-            <a:ext cx="2181013" cy="261610"/>
-          </a:xfrm>
-          <a:prstGeom prst="rect">
-            <a:avLst/>
-          </a:prstGeom>
-          <a:noFill/>
-        </p:spPr>
-        <p:txBody>
-          <a:bodyPr wrap="square" rtlCol="0">
-            <a:spAutoFit/>
-          </a:bodyPr>
-          <a:lstStyle/>
-          <a:p>
-            <a:pPr algn="ctr"/>
-            <a:r>
-              <a:rPr lang="pl-PL" sz="1100" dirty="0">
-                <a:solidFill>
-                  <a:srgbClr val="504C49"/>
-                </a:solidFill>
-                <a:latin typeface="Source Serif 4" pitchFamily="34" charset="0"/>
-                <a:ea typeface="Source Serif 4" pitchFamily="34" charset="-122"/>
-              </a:rPr>
-              <a:t>Pętla </a:t>
-            </a:r>
-            <a:r>
-              <a:rPr lang="pl-PL" sz="1100" noProof="0" dirty="0">
-                <a:solidFill>
-                  <a:srgbClr val="504C49"/>
-                </a:solidFill>
-                <a:latin typeface="Source Serif 4" pitchFamily="34" charset="0"/>
-                <a:ea typeface="Source Serif 4" pitchFamily="34" charset="-122"/>
-              </a:rPr>
-              <a:t>MLOps</a:t>
-            </a:r>
-            <a:endParaRPr lang="pl-PL" sz="1100" dirty="0">
-              <a:solidFill>
-                <a:srgbClr val="504C49"/>
-              </a:solidFill>
-              <a:latin typeface="Source Serif 4" pitchFamily="34" charset="0"/>
-              <a:ea typeface="Source Serif 4" pitchFamily="34" charset="-122"/>
-            </a:endParaRPr>
-          </a:p>
-        </p:txBody>
-      </p:sp>
-    </p:spTree>
-  </p:cSld>
-  <p:clrMapOvr>
-    <a:masterClrMapping/>
-  </p:clrMapOvr>
-</p:sld>
-</file>
-
-<file path=ppt/slides/slide6.xml><?xml version="1.0" encoding="utf-8"?>
+<file path=ppt/slides/slide7.xml><?xml version="1.0" encoding="utf-8"?>
 <p:sld xmlns:a="http://schemas.openxmlformats.org/drawingml/2006/main" xmlns:r="http://schemas.openxmlformats.org/officeDocument/2006/relationships" xmlns:p="http://schemas.openxmlformats.org/presentationml/2006/main" showMasterSp="0">
   <p:cSld name="Slide 6">
     <p:bg>
@@ -4854,7 +5613,7 @@
         </p:nvSpPr>
         <p:spPr>
           <a:xfrm>
-            <a:off x="496119" y="431304"/>
+            <a:off x="496119" y="1034732"/>
             <a:ext cx="921841" cy="214759"/>
           </a:xfrm>
           <a:prstGeom prst="roundRect">
@@ -4867,6 +5626,13 @@
           </a:solidFill>
           <a:ln/>
         </p:spPr>
+        <p:txBody>
+          <a:bodyPr/>
+          <a:lstStyle/>
+          <a:p>
+            <a:endParaRPr lang="pl-PL" noProof="0" dirty="0"/>
+          </a:p>
+        </p:txBody>
       </p:sp>
       <p:sp>
         <p:nvSpPr>
@@ -4876,7 +5642,7 @@
         </p:nvSpPr>
         <p:spPr>
           <a:xfrm>
-            <a:off x="568375" y="467395"/>
+            <a:off x="568375" y="1070823"/>
             <a:ext cx="777329" cy="142577"/>
           </a:xfrm>
           <a:prstGeom prst="rect">
@@ -4896,7 +5662,7 @@
               <a:buNone/>
             </a:pPr>
             <a:r>
-              <a:rPr lang="en-US" sz="750" dirty="0">
+              <a:rPr lang="pl-PL" sz="750" noProof="0" dirty="0">
                 <a:solidFill>
                   <a:srgbClr val="504C49"/>
                 </a:solidFill>
@@ -4906,7 +5672,7 @@
               </a:rPr>
               <a:t>NIEZAWODNOŚĆ</a:t>
             </a:r>
-            <a:endParaRPr lang="en-US" sz="750" dirty="0"/>
+            <a:endParaRPr lang="pl-PL" sz="750" noProof="0" dirty="0"/>
           </a:p>
         </p:txBody>
       </p:sp>
@@ -4918,8 +5684,8 @@
         </p:nvSpPr>
         <p:spPr>
           <a:xfrm>
-            <a:off x="496119" y="686991"/>
-            <a:ext cx="5769173" cy="376535"/>
+            <a:off x="496119" y="1290419"/>
+            <a:ext cx="7516734" cy="376535"/>
           </a:xfrm>
           <a:prstGeom prst="rect">
             <a:avLst/>
@@ -4931,14 +5697,13 @@
           <a:bodyPr wrap="none" lIns="0" tIns="0" rIns="0" bIns="0" rtlCol="0" anchor="t"/>
           <a:lstStyle/>
           <a:p>
-            <a:pPr marL="0" indent="0" algn="l">
+            <a:pPr>
               <a:lnSpc>
                 <a:spcPts val="2950"/>
               </a:lnSpc>
-              <a:buNone/>
             </a:pPr>
             <a:r>
-              <a:rPr lang="en-US" sz="2350" dirty="0">
+              <a:rPr lang="pl-PL" sz="2350" noProof="0" dirty="0">
                 <a:solidFill>
                   <a:srgbClr val="201B18"/>
                 </a:solidFill>
@@ -4946,9 +5711,9 @@
                 <a:ea typeface="Platypi Medium" pitchFamily="34" charset="-122"/>
                 <a:cs typeface="Platypi Medium" pitchFamily="34" charset="-120"/>
               </a:rPr>
-              <a:t>3-fazowe naprawianie odpowiedzi LLM</a:t>
-            </a:r>
-            <a:endParaRPr lang="en-US" sz="2350" dirty="0"/>
+              <a:t>Mechanizmy zwiększające niezawodność systemu</a:t>
+            </a:r>
+            <a:endParaRPr lang="pl-PL" sz="2350" noProof="0" dirty="0"/>
           </a:p>
         </p:txBody>
       </p:sp>
@@ -4960,7 +5725,7 @@
         </p:nvSpPr>
         <p:spPr>
           <a:xfrm>
-            <a:off x="496119" y="1332309"/>
+            <a:off x="496119" y="2069746"/>
             <a:ext cx="240953" cy="150614"/>
           </a:xfrm>
           <a:prstGeom prst="rect">
@@ -4980,7 +5745,7 @@
               <a:buNone/>
             </a:pPr>
             <a:r>
-              <a:rPr lang="en-US" sz="900" dirty="0">
+              <a:rPr lang="pl-PL" sz="900" noProof="0" dirty="0">
                 <a:solidFill>
                   <a:srgbClr val="504C49"/>
                 </a:solidFill>
@@ -4990,7 +5755,7 @@
               </a:rPr>
               <a:t>01</a:t>
             </a:r>
-            <a:endParaRPr lang="en-US" sz="900" dirty="0"/>
+            <a:endParaRPr lang="pl-PL" sz="900" noProof="0" dirty="0"/>
           </a:p>
         </p:txBody>
       </p:sp>
@@ -5002,7 +5767,7 @@
         </p:nvSpPr>
         <p:spPr>
           <a:xfrm>
-            <a:off x="496119" y="1522735"/>
+            <a:off x="496119" y="2260172"/>
             <a:ext cx="4351139" cy="14288"/>
           </a:xfrm>
           <a:prstGeom prst="rect">
@@ -5013,6 +5778,13 @@
           </a:solidFill>
           <a:ln/>
         </p:spPr>
+        <p:txBody>
+          <a:bodyPr/>
+          <a:lstStyle/>
+          <a:p>
+            <a:endParaRPr lang="pl-PL" noProof="0" dirty="0"/>
+          </a:p>
+        </p:txBody>
       </p:sp>
       <p:sp>
         <p:nvSpPr>
@@ -5022,8 +5794,228 @@
         </p:nvSpPr>
         <p:spPr>
           <a:xfrm>
-            <a:off x="496119" y="1611511"/>
-            <a:ext cx="1779389" cy="188268"/>
+            <a:off x="496119" y="2386602"/>
+            <a:ext cx="4351139" cy="150614"/>
+          </a:xfrm>
+          <a:prstGeom prst="rect">
+            <a:avLst/>
+          </a:prstGeom>
+          <a:noFill/>
+          <a:ln/>
+        </p:spPr>
+        <p:txBody>
+          <a:bodyPr wrap="none" lIns="0" tIns="0" rIns="0" bIns="0" rtlCol="0" anchor="t"/>
+          <a:lstStyle/>
+          <a:p>
+            <a:pPr>
+              <a:lnSpc>
+                <a:spcPts val="1450"/>
+              </a:lnSpc>
+            </a:pPr>
+            <a:r>
+              <a:rPr lang="pl-PL" sz="1150" noProof="0" dirty="0">
+                <a:solidFill>
+                  <a:srgbClr val="504C49"/>
+                </a:solidFill>
+                <a:latin typeface="Platypi Medium" pitchFamily="34" charset="0"/>
+                <a:ea typeface="Platypi Medium" pitchFamily="34" charset="-122"/>
+                <a:cs typeface="Platypi Medium" pitchFamily="34" charset="-120"/>
+              </a:rPr>
+              <a:t>Walidacja struktury odpowiedzi</a:t>
+            </a:r>
+            <a:endParaRPr lang="pl-PL" sz="1150" noProof="0" dirty="0"/>
+          </a:p>
+        </p:txBody>
+      </p:sp>
+      <p:sp>
+        <p:nvSpPr>
+          <p:cNvPr id="9" name="Text 7"/>
+          <p:cNvSpPr/>
+          <p:nvPr/>
+        </p:nvSpPr>
+        <p:spPr>
+          <a:xfrm>
+            <a:off x="496119" y="2823822"/>
+            <a:ext cx="240953" cy="150614"/>
+          </a:xfrm>
+          <a:prstGeom prst="rect">
+            <a:avLst/>
+          </a:prstGeom>
+          <a:noFill/>
+          <a:ln/>
+        </p:spPr>
+        <p:txBody>
+          <a:bodyPr wrap="none" lIns="0" tIns="0" rIns="0" bIns="0" rtlCol="0" anchor="ctr"/>
+          <a:lstStyle/>
+          <a:p>
+            <a:pPr marL="0" indent="0" algn="l">
+              <a:lnSpc>
+                <a:spcPct val="100000"/>
+              </a:lnSpc>
+              <a:buNone/>
+            </a:pPr>
+            <a:r>
+              <a:rPr lang="pl-PL" sz="900" noProof="0" dirty="0">
+                <a:solidFill>
+                  <a:srgbClr val="504C49"/>
+                </a:solidFill>
+                <a:latin typeface="Platypi Light" pitchFamily="34" charset="0"/>
+                <a:ea typeface="Platypi Light" pitchFamily="34" charset="-122"/>
+                <a:cs typeface="Platypi Light" pitchFamily="34" charset="-120"/>
+              </a:rPr>
+              <a:t>02</a:t>
+            </a:r>
+            <a:endParaRPr lang="pl-PL" sz="900" noProof="0" dirty="0"/>
+          </a:p>
+        </p:txBody>
+      </p:sp>
+      <p:sp>
+        <p:nvSpPr>
+          <p:cNvPr id="10" name="Shape 8"/>
+          <p:cNvSpPr/>
+          <p:nvPr/>
+        </p:nvSpPr>
+        <p:spPr>
+          <a:xfrm>
+            <a:off x="496119" y="3014247"/>
+            <a:ext cx="4351139" cy="14288"/>
+          </a:xfrm>
+          <a:prstGeom prst="rect">
+            <a:avLst/>
+          </a:prstGeom>
+          <a:solidFill>
+            <a:srgbClr val="3E2513"/>
+          </a:solidFill>
+          <a:ln/>
+        </p:spPr>
+        <p:txBody>
+          <a:bodyPr/>
+          <a:lstStyle/>
+          <a:p>
+            <a:endParaRPr lang="pl-PL" noProof="0" dirty="0"/>
+          </a:p>
+        </p:txBody>
+      </p:sp>
+      <p:sp>
+        <p:nvSpPr>
+          <p:cNvPr id="11" name="Text 9"/>
+          <p:cNvSpPr/>
+          <p:nvPr/>
+        </p:nvSpPr>
+        <p:spPr>
+          <a:xfrm>
+            <a:off x="496119" y="3140677"/>
+            <a:ext cx="4351139" cy="150614"/>
+          </a:xfrm>
+          <a:prstGeom prst="rect">
+            <a:avLst/>
+          </a:prstGeom>
+          <a:noFill/>
+          <a:ln/>
+        </p:spPr>
+        <p:txBody>
+          <a:bodyPr wrap="none" lIns="0" tIns="0" rIns="0" bIns="0" rtlCol="0" anchor="t"/>
+          <a:lstStyle/>
+          <a:p>
+            <a:pPr>
+              <a:lnSpc>
+                <a:spcPts val="1450"/>
+              </a:lnSpc>
+            </a:pPr>
+            <a:r>
+              <a:rPr lang="pl-PL" sz="1150" noProof="0" dirty="0">
+                <a:solidFill>
+                  <a:srgbClr val="504C49"/>
+                </a:solidFill>
+                <a:latin typeface="Platypi Medium" pitchFamily="34" charset="0"/>
+                <a:ea typeface="Platypi Medium" pitchFamily="34" charset="-122"/>
+                <a:cs typeface="Platypi Medium" pitchFamily="34" charset="-120"/>
+              </a:rPr>
+              <a:t>Automatyczna naprawa formatu</a:t>
+            </a:r>
+            <a:endParaRPr lang="pl-PL" sz="1150" noProof="0" dirty="0"/>
+          </a:p>
+        </p:txBody>
+      </p:sp>
+      <p:sp>
+        <p:nvSpPr>
+          <p:cNvPr id="13" name="Text 11"/>
+          <p:cNvSpPr/>
+          <p:nvPr/>
+        </p:nvSpPr>
+        <p:spPr>
+          <a:xfrm>
+            <a:off x="496119" y="3580277"/>
+            <a:ext cx="240953" cy="150614"/>
+          </a:xfrm>
+          <a:prstGeom prst="rect">
+            <a:avLst/>
+          </a:prstGeom>
+          <a:noFill/>
+          <a:ln/>
+        </p:spPr>
+        <p:txBody>
+          <a:bodyPr wrap="none" lIns="0" tIns="0" rIns="0" bIns="0" rtlCol="0" anchor="ctr"/>
+          <a:lstStyle/>
+          <a:p>
+            <a:pPr marL="0" indent="0" algn="l">
+              <a:lnSpc>
+                <a:spcPct val="100000"/>
+              </a:lnSpc>
+              <a:buNone/>
+            </a:pPr>
+            <a:r>
+              <a:rPr lang="pl-PL" sz="900" noProof="0" dirty="0">
+                <a:solidFill>
+                  <a:srgbClr val="504C49"/>
+                </a:solidFill>
+                <a:latin typeface="Platypi Light" pitchFamily="34" charset="0"/>
+                <a:ea typeface="Platypi Light" pitchFamily="34" charset="-122"/>
+                <a:cs typeface="Platypi Light" pitchFamily="34" charset="-120"/>
+              </a:rPr>
+              <a:t>03</a:t>
+            </a:r>
+            <a:endParaRPr lang="pl-PL" sz="900" noProof="0" dirty="0"/>
+          </a:p>
+        </p:txBody>
+      </p:sp>
+      <p:sp>
+        <p:nvSpPr>
+          <p:cNvPr id="14" name="Shape 12"/>
+          <p:cNvSpPr/>
+          <p:nvPr/>
+        </p:nvSpPr>
+        <p:spPr>
+          <a:xfrm>
+            <a:off x="496119" y="3770703"/>
+            <a:ext cx="4351139" cy="14288"/>
+          </a:xfrm>
+          <a:prstGeom prst="rect">
+            <a:avLst/>
+          </a:prstGeom>
+          <a:solidFill>
+            <a:srgbClr val="3E2513"/>
+          </a:solidFill>
+          <a:ln/>
+        </p:spPr>
+        <p:txBody>
+          <a:bodyPr/>
+          <a:lstStyle/>
+          <a:p>
+            <a:endParaRPr lang="pl-PL" noProof="0" dirty="0"/>
+          </a:p>
+        </p:txBody>
+      </p:sp>
+      <p:sp>
+        <p:nvSpPr>
+          <p:cNvPr id="15" name="Text 13"/>
+          <p:cNvSpPr/>
+          <p:nvPr/>
+        </p:nvSpPr>
+        <p:spPr>
+          <a:xfrm>
+            <a:off x="496119" y="3859479"/>
+            <a:ext cx="1506215" cy="188268"/>
           </a:xfrm>
           <a:prstGeom prst="rect">
             <a:avLst/>
@@ -5042,7 +6034,7 @@
               <a:buNone/>
             </a:pPr>
             <a:r>
-              <a:rPr lang="en-US" sz="1150" dirty="0">
+              <a:rPr lang="pl-PL" sz="1150" noProof="0" dirty="0">
                 <a:solidFill>
                   <a:srgbClr val="504C49"/>
                 </a:solidFill>
@@ -5050,126 +6042,51 @@
                 <a:ea typeface="Platypi Medium" pitchFamily="34" charset="-122"/>
                 <a:cs typeface="Platypi Medium" pitchFamily="34" charset="-120"/>
               </a:rPr>
-              <a:t>Ścisłe parsowanie JSON</a:t>
-            </a:r>
-            <a:endParaRPr lang="en-US" sz="1150" dirty="0"/>
-          </a:p>
-        </p:txBody>
-      </p:sp>
-      <p:sp>
-        <p:nvSpPr>
-          <p:cNvPr id="8" name="Text 6"/>
-          <p:cNvSpPr/>
-          <p:nvPr/>
-        </p:nvSpPr>
-        <p:spPr>
-          <a:xfrm>
-            <a:off x="496119" y="1902172"/>
-            <a:ext cx="4351139" cy="356592"/>
-          </a:xfrm>
-          <a:prstGeom prst="rect">
-            <a:avLst/>
-          </a:prstGeom>
-          <a:noFill/>
-          <a:ln/>
-        </p:spPr>
-        <p:txBody>
-          <a:bodyPr wrap="square" lIns="0" tIns="0" rIns="0" bIns="0" rtlCol="0" anchor="t"/>
-          <a:lstStyle/>
-          <a:p>
-            <a:pPr marL="0" indent="0" algn="l">
-              <a:lnSpc>
-                <a:spcPts val="1400"/>
-              </a:lnSpc>
-              <a:buNone/>
-            </a:pPr>
-            <a:r>
-              <a:rPr lang="en-US" sz="900" dirty="0">
-                <a:solidFill>
-                  <a:srgbClr val="504C49"/>
-                </a:solidFill>
-                <a:latin typeface="Source Serif 4" pitchFamily="34" charset="0"/>
-                <a:ea typeface="Source Serif 4" pitchFamily="34" charset="-122"/>
-                <a:cs typeface="Source Serif 4" pitchFamily="34" charset="-120"/>
-              </a:rPr>
-              <a:t>Próba bezpośredniej deserializacji odpowiedzi modelu zgodnie ze zdefiniowanym schematem wyjściowym.</a:t>
-            </a:r>
-            <a:endParaRPr lang="en-US" sz="900" dirty="0"/>
-          </a:p>
-        </p:txBody>
-      </p:sp>
-      <p:sp>
-        <p:nvSpPr>
-          <p:cNvPr id="9" name="Text 7"/>
-          <p:cNvSpPr/>
-          <p:nvPr/>
-        </p:nvSpPr>
-        <p:spPr>
-          <a:xfrm>
-            <a:off x="496119" y="2451497"/>
-            <a:ext cx="240953" cy="150614"/>
-          </a:xfrm>
-          <a:prstGeom prst="rect">
-            <a:avLst/>
-          </a:prstGeom>
-          <a:noFill/>
-          <a:ln/>
-        </p:spPr>
-        <p:txBody>
-          <a:bodyPr wrap="none" lIns="0" tIns="0" rIns="0" bIns="0" rtlCol="0" anchor="ctr"/>
-          <a:lstStyle/>
-          <a:p>
-            <a:pPr marL="0" indent="0" algn="l">
-              <a:lnSpc>
-                <a:spcPct val="100000"/>
-              </a:lnSpc>
-              <a:buNone/>
-            </a:pPr>
-            <a:r>
-              <a:rPr lang="en-US" sz="900" dirty="0">
-                <a:solidFill>
-                  <a:srgbClr val="504C49"/>
-                </a:solidFill>
-                <a:latin typeface="Platypi Light" pitchFamily="34" charset="0"/>
-                <a:ea typeface="Platypi Light" pitchFamily="34" charset="-122"/>
-                <a:cs typeface="Platypi Light" pitchFamily="34" charset="-120"/>
-              </a:rPr>
-              <a:t>02</a:t>
-            </a:r>
-            <a:endParaRPr lang="en-US" sz="900" dirty="0"/>
-          </a:p>
-        </p:txBody>
-      </p:sp>
-      <p:sp>
-        <p:nvSpPr>
-          <p:cNvPr id="10" name="Shape 8"/>
-          <p:cNvSpPr/>
-          <p:nvPr/>
-        </p:nvSpPr>
-        <p:spPr>
-          <a:xfrm>
-            <a:off x="496119" y="2641922"/>
-            <a:ext cx="4351139" cy="14288"/>
-          </a:xfrm>
-          <a:prstGeom prst="rect">
-            <a:avLst/>
+              <a:t>Normalizacja tagów</a:t>
+            </a:r>
+            <a:endParaRPr lang="pl-PL" sz="1150" noProof="0" dirty="0"/>
+          </a:p>
+        </p:txBody>
+      </p:sp>
+      <p:sp>
+        <p:nvSpPr>
+          <p:cNvPr id="17" name="Shape 15"/>
+          <p:cNvSpPr/>
+          <p:nvPr/>
+        </p:nvSpPr>
+        <p:spPr>
+          <a:xfrm>
+            <a:off x="5059189" y="2001509"/>
+            <a:ext cx="3680147" cy="2372751"/>
+          </a:xfrm>
+          <a:prstGeom prst="roundRect">
+            <a:avLst>
+              <a:gd name="adj" fmla="val 517"/>
+            </a:avLst>
           </a:prstGeom>
           <a:solidFill>
-            <a:srgbClr val="3E2513"/>
+            <a:srgbClr val="1A3A52"/>
           </a:solidFill>
           <a:ln/>
         </p:spPr>
-      </p:sp>
-      <p:sp>
-        <p:nvSpPr>
-          <p:cNvPr id="11" name="Text 9"/>
-          <p:cNvSpPr/>
-          <p:nvPr/>
-        </p:nvSpPr>
-        <p:spPr>
-          <a:xfrm>
-            <a:off x="496119" y="2730698"/>
-            <a:ext cx="1921669" cy="188268"/>
+        <p:txBody>
+          <a:bodyPr/>
+          <a:lstStyle/>
+          <a:p>
+            <a:endParaRPr lang="pl-PL" noProof="0" dirty="0"/>
+          </a:p>
+        </p:txBody>
+      </p:sp>
+      <p:sp>
+        <p:nvSpPr>
+          <p:cNvPr id="18" name="Text 16"/>
+          <p:cNvSpPr/>
+          <p:nvPr/>
+        </p:nvSpPr>
+        <p:spPr>
+          <a:xfrm>
+            <a:off x="5179665" y="2103903"/>
+            <a:ext cx="2328714" cy="188268"/>
           </a:xfrm>
           <a:prstGeom prst="rect">
             <a:avLst/>
@@ -5188,319 +6105,17 @@
               <a:buNone/>
             </a:pPr>
             <a:r>
-              <a:rPr lang="en-US" sz="1150" dirty="0">
-                <a:solidFill>
-                  <a:srgbClr val="504C49"/>
+              <a:rPr lang="pl-PL" sz="1150" noProof="0" dirty="0">
+                <a:solidFill>
+                  <a:srgbClr val="FFFFFF"/>
                 </a:solidFill>
                 <a:latin typeface="Platypi Medium" pitchFamily="34" charset="0"/>
                 <a:ea typeface="Platypi Medium" pitchFamily="34" charset="-122"/>
                 <a:cs typeface="Platypi Medium" pitchFamily="34" charset="-120"/>
               </a:rPr>
-              <a:t>Odzyskiwanie przez regex</a:t>
-            </a:r>
-            <a:endParaRPr lang="en-US" sz="1150" dirty="0"/>
-          </a:p>
-        </p:txBody>
-      </p:sp>
-      <p:sp>
-        <p:nvSpPr>
-          <p:cNvPr id="12" name="Text 10"/>
-          <p:cNvSpPr/>
-          <p:nvPr/>
-        </p:nvSpPr>
-        <p:spPr>
-          <a:xfrm>
-            <a:off x="496119" y="3021360"/>
-            <a:ext cx="4351139" cy="356592"/>
-          </a:xfrm>
-          <a:prstGeom prst="rect">
-            <a:avLst/>
-          </a:prstGeom>
-          <a:noFill/>
-          <a:ln/>
-        </p:spPr>
-        <p:txBody>
-          <a:bodyPr wrap="square" lIns="0" tIns="0" rIns="0" bIns="0" rtlCol="0" anchor="t"/>
-          <a:lstStyle/>
-          <a:p>
-            <a:pPr marL="0" indent="0" algn="l">
-              <a:lnSpc>
-                <a:spcPts val="1400"/>
-              </a:lnSpc>
-              <a:buNone/>
-            </a:pPr>
-            <a:r>
-              <a:rPr lang="en-US" sz="900" dirty="0">
-                <a:solidFill>
-                  <a:srgbClr val="504C49"/>
-                </a:solidFill>
-                <a:latin typeface="Source Serif 4" pitchFamily="34" charset="0"/>
-                <a:ea typeface="Source Serif 4" pitchFamily="34" charset="-122"/>
-                <a:cs typeface="Source Serif 4" pitchFamily="34" charset="-120"/>
-              </a:rPr>
-              <a:t>Automatyczna naprawa typowych błędów strukturalnych: brakujące nawiasy, niepoprawne klucze, ucięte wartości.</a:t>
-            </a:r>
-            <a:endParaRPr lang="en-US" sz="900" dirty="0"/>
-          </a:p>
-        </p:txBody>
-      </p:sp>
-      <p:sp>
-        <p:nvSpPr>
-          <p:cNvPr id="13" name="Text 11"/>
-          <p:cNvSpPr/>
-          <p:nvPr/>
-        </p:nvSpPr>
-        <p:spPr>
-          <a:xfrm>
-            <a:off x="496119" y="3570684"/>
-            <a:ext cx="240953" cy="150614"/>
-          </a:xfrm>
-          <a:prstGeom prst="rect">
-            <a:avLst/>
-          </a:prstGeom>
-          <a:noFill/>
-          <a:ln/>
-        </p:spPr>
-        <p:txBody>
-          <a:bodyPr wrap="none" lIns="0" tIns="0" rIns="0" bIns="0" rtlCol="0" anchor="ctr"/>
-          <a:lstStyle/>
-          <a:p>
-            <a:pPr marL="0" indent="0" algn="l">
-              <a:lnSpc>
-                <a:spcPct val="100000"/>
-              </a:lnSpc>
-              <a:buNone/>
-            </a:pPr>
-            <a:r>
-              <a:rPr lang="en-US" sz="900" dirty="0">
-                <a:solidFill>
-                  <a:srgbClr val="504C49"/>
-                </a:solidFill>
-                <a:latin typeface="Platypi Light" pitchFamily="34" charset="0"/>
-                <a:ea typeface="Platypi Light" pitchFamily="34" charset="-122"/>
-                <a:cs typeface="Platypi Light" pitchFamily="34" charset="-120"/>
-              </a:rPr>
-              <a:t>03</a:t>
-            </a:r>
-            <a:endParaRPr lang="en-US" sz="900" dirty="0"/>
-          </a:p>
-        </p:txBody>
-      </p:sp>
-      <p:sp>
-        <p:nvSpPr>
-          <p:cNvPr id="14" name="Shape 12"/>
-          <p:cNvSpPr/>
-          <p:nvPr/>
-        </p:nvSpPr>
-        <p:spPr>
-          <a:xfrm>
-            <a:off x="496119" y="3761110"/>
-            <a:ext cx="4351139" cy="14288"/>
-          </a:xfrm>
-          <a:prstGeom prst="rect">
-            <a:avLst/>
-          </a:prstGeom>
-          <a:solidFill>
-            <a:srgbClr val="3E2513"/>
-          </a:solidFill>
-          <a:ln/>
-        </p:spPr>
-      </p:sp>
-      <p:sp>
-        <p:nvSpPr>
-          <p:cNvPr id="15" name="Text 13"/>
-          <p:cNvSpPr/>
-          <p:nvPr/>
-        </p:nvSpPr>
-        <p:spPr>
-          <a:xfrm>
-            <a:off x="496119" y="3849886"/>
-            <a:ext cx="1506215" cy="188268"/>
-          </a:xfrm>
-          <a:prstGeom prst="rect">
-            <a:avLst/>
-          </a:prstGeom>
-          <a:noFill/>
-          <a:ln/>
-        </p:spPr>
-        <p:txBody>
-          <a:bodyPr wrap="none" lIns="0" tIns="0" rIns="0" bIns="0" rtlCol="0" anchor="t"/>
-          <a:lstStyle/>
-          <a:p>
-            <a:pPr marL="0" indent="0" algn="l">
-              <a:lnSpc>
-                <a:spcPts val="1450"/>
-              </a:lnSpc>
-              <a:buNone/>
-            </a:pPr>
-            <a:r>
-              <a:rPr lang="en-US" sz="1150" dirty="0">
-                <a:solidFill>
-                  <a:srgbClr val="504C49"/>
-                </a:solidFill>
-                <a:latin typeface="Platypi Medium" pitchFamily="34" charset="0"/>
-                <a:ea typeface="Platypi Medium" pitchFamily="34" charset="-122"/>
-                <a:cs typeface="Platypi Medium" pitchFamily="34" charset="-120"/>
-              </a:rPr>
-              <a:t>Normalizacja tagów</a:t>
-            </a:r>
-            <a:endParaRPr lang="en-US" sz="1150" dirty="0"/>
-          </a:p>
-        </p:txBody>
-      </p:sp>
-      <p:sp>
-        <p:nvSpPr>
-          <p:cNvPr id="16" name="Text 14"/>
-          <p:cNvSpPr/>
-          <p:nvPr/>
-        </p:nvSpPr>
-        <p:spPr>
-          <a:xfrm>
-            <a:off x="496119" y="4140547"/>
-            <a:ext cx="4351139" cy="366117"/>
-          </a:xfrm>
-          <a:prstGeom prst="rect">
-            <a:avLst/>
-          </a:prstGeom>
-          <a:noFill/>
-          <a:ln/>
-        </p:spPr>
-        <p:txBody>
-          <a:bodyPr wrap="square" lIns="0" tIns="0" rIns="0" bIns="0" rtlCol="0" anchor="t"/>
-          <a:lstStyle/>
-          <a:p>
-            <a:pPr marL="0" indent="0" algn="l">
-              <a:lnSpc>
-                <a:spcPts val="1400"/>
-              </a:lnSpc>
-              <a:buNone/>
-            </a:pPr>
-            <a:r>
-              <a:rPr lang="en-US" sz="900" dirty="0">
-                <a:solidFill>
-                  <a:srgbClr val="504C49"/>
-                </a:solidFill>
-                <a:latin typeface="Source Serif 4" pitchFamily="34" charset="0"/>
-                <a:ea typeface="Source Serif 4" pitchFamily="34" charset="-122"/>
-                <a:cs typeface="Source Serif 4" pitchFamily="34" charset="-120"/>
-              </a:rPr>
-              <a:t>Korekcja błędów ortograficznych w etykietach technik, np. </a:t>
-            </a:r>
-            <a:r>
-              <a:rPr lang="en-US" sz="900" dirty="0">
-                <a:solidFill>
-                  <a:srgbClr val="504C49"/>
-                </a:solidFill>
-                <a:highlight>
-                  <a:srgbClr val="F2F2F2"/>
-                </a:highlight>
-                <a:latin typeface="Consolas" pitchFamily="34" charset="0"/>
-                <a:ea typeface="Consolas" pitchFamily="34" charset="-122"/>
-                <a:cs typeface="Consolas" pitchFamily="34" charset="-120"/>
-              </a:rPr>
-              <a:t>EMOTIORAL</a:t>
-            </a:r>
-            <a:r>
-              <a:rPr lang="en-US" sz="900" dirty="0">
-                <a:solidFill>
-                  <a:srgbClr val="504C49"/>
-                </a:solidFill>
-                <a:latin typeface="Source Serif 4" pitchFamily="34" charset="0"/>
-                <a:ea typeface="Source Serif 4" pitchFamily="34" charset="-122"/>
-                <a:cs typeface="Source Serif 4" pitchFamily="34" charset="-120"/>
-              </a:rPr>
-              <a:t> → </a:t>
-            </a:r>
-            <a:r>
-              <a:rPr lang="en-US" sz="900" dirty="0">
-                <a:solidFill>
-                  <a:srgbClr val="504C49"/>
-                </a:solidFill>
-                <a:highlight>
-                  <a:srgbClr val="F2F2F2"/>
-                </a:highlight>
-                <a:latin typeface="Consolas" pitchFamily="34" charset="0"/>
-                <a:ea typeface="Consolas" pitchFamily="34" charset="-122"/>
-                <a:cs typeface="Consolas" pitchFamily="34" charset="-120"/>
-              </a:rPr>
-              <a:t>EMOTIONAL</a:t>
-            </a:r>
-            <a:r>
-              <a:rPr lang="en-US" sz="900" dirty="0">
-                <a:solidFill>
-                  <a:srgbClr val="504C49"/>
-                </a:solidFill>
-                <a:latin typeface="Source Serif 4" pitchFamily="34" charset="0"/>
-                <a:ea typeface="Source Serif 4" pitchFamily="34" charset="-122"/>
-                <a:cs typeface="Source Serif 4" pitchFamily="34" charset="-120"/>
-              </a:rPr>
-              <a:t>.</a:t>
-            </a:r>
-            <a:endParaRPr lang="en-US" sz="900" dirty="0"/>
-          </a:p>
-        </p:txBody>
-      </p:sp>
-      <p:sp>
-        <p:nvSpPr>
-          <p:cNvPr id="17" name="Shape 15"/>
-          <p:cNvSpPr/>
-          <p:nvPr/>
-        </p:nvSpPr>
-        <p:spPr>
-          <a:xfrm>
-            <a:off x="5059189" y="1217116"/>
-            <a:ext cx="3680147" cy="3495080"/>
-          </a:xfrm>
-          <a:prstGeom prst="roundRect">
-            <a:avLst>
-              <a:gd name="adj" fmla="val 517"/>
-            </a:avLst>
-          </a:prstGeom>
-          <a:solidFill>
-            <a:srgbClr val="1A3A52"/>
-          </a:solidFill>
-          <a:ln/>
-        </p:spPr>
-      </p:sp>
-      <p:sp>
-        <p:nvSpPr>
-          <p:cNvPr id="18" name="Text 16"/>
-          <p:cNvSpPr/>
-          <p:nvPr/>
-        </p:nvSpPr>
-        <p:spPr>
-          <a:xfrm>
-            <a:off x="5179665" y="1319510"/>
-            <a:ext cx="2328714" cy="188268"/>
-          </a:xfrm>
-          <a:prstGeom prst="rect">
-            <a:avLst/>
-          </a:prstGeom>
-          <a:noFill/>
-          <a:ln/>
-        </p:spPr>
-        <p:txBody>
-          <a:bodyPr wrap="none" lIns="0" tIns="0" rIns="0" bIns="0" rtlCol="0" anchor="t"/>
-          <a:lstStyle/>
-          <a:p>
-            <a:pPr marL="0" indent="0" algn="l">
-              <a:lnSpc>
-                <a:spcPts val="1450"/>
-              </a:lnSpc>
-              <a:buNone/>
-            </a:pPr>
-            <a:r>
-              <a:rPr lang="en-US" sz="1150" dirty="0">
-                <a:solidFill>
-                  <a:srgbClr val="FFFFFF"/>
-                </a:solidFill>
-                <a:latin typeface="Platypi Medium" pitchFamily="34" charset="0"/>
-                <a:ea typeface="Platypi Medium" pitchFamily="34" charset="-122"/>
-                <a:cs typeface="Platypi Medium" pitchFamily="34" charset="-120"/>
-              </a:rPr>
               <a:t>Wskaźnik poprawnej struktury</a:t>
             </a:r>
-            <a:endParaRPr lang="en-US" sz="1150" dirty="0"/>
+            <a:endParaRPr lang="pl-PL" sz="1150" noProof="0" dirty="0"/>
           </a:p>
         </p:txBody>
       </p:sp>
@@ -5512,7 +6127,7 @@
         </p:nvSpPr>
         <p:spPr>
           <a:xfrm>
-            <a:off x="5179665" y="1610171"/>
+            <a:off x="5179665" y="2394564"/>
             <a:ext cx="3439195" cy="753145"/>
           </a:xfrm>
           <a:prstGeom prst="rect">
@@ -5532,7 +6147,7 @@
               <a:buNone/>
             </a:pPr>
             <a:r>
-              <a:rPr lang="en-US" sz="4700" dirty="0">
+              <a:rPr lang="pl-PL" sz="4700" noProof="0" dirty="0">
                 <a:solidFill>
                   <a:srgbClr val="FFFFFF"/>
                 </a:solidFill>
@@ -5542,7 +6157,7 @@
               </a:rPr>
               <a:t>96%+</a:t>
             </a:r>
-            <a:endParaRPr lang="en-US" sz="4700" dirty="0"/>
+            <a:endParaRPr lang="pl-PL" sz="4700" noProof="0" dirty="0"/>
           </a:p>
         </p:txBody>
       </p:sp>
@@ -5554,7 +6169,7 @@
         </p:nvSpPr>
         <p:spPr>
           <a:xfrm>
-            <a:off x="5179665" y="2465710"/>
+            <a:off x="5179665" y="3250103"/>
             <a:ext cx="3439195" cy="534888"/>
           </a:xfrm>
           <a:prstGeom prst="rect">
@@ -5567,14 +6182,14 @@
           <a:bodyPr wrap="square" lIns="0" tIns="0" rIns="0" bIns="0" rtlCol="0" anchor="t"/>
           <a:lstStyle/>
           <a:p>
-            <a:pPr marL="0" indent="0" algn="ctr">
+            <a:pPr marL="0" indent="0">
               <a:lnSpc>
                 <a:spcPts val="1400"/>
               </a:lnSpc>
               <a:buNone/>
             </a:pPr>
             <a:r>
-              <a:rPr lang="en-US" sz="900" b="1" dirty="0">
+              <a:rPr lang="pl-PL" sz="1100" b="1" noProof="0" dirty="0">
                 <a:solidFill>
                   <a:srgbClr val="FFFFFF"/>
                 </a:solidFill>
@@ -5585,7 +6200,7 @@
               <a:t>PSR (Parse Success Rate)</a:t>
             </a:r>
             <a:r>
-              <a:rPr lang="en-US" sz="900" dirty="0">
+              <a:rPr lang="pl-PL" sz="1100" noProof="0" dirty="0">
                 <a:solidFill>
                   <a:srgbClr val="FFFFFF"/>
                 </a:solidFill>
@@ -5595,7 +6210,7 @@
               </a:rPr>
               <a:t> — skuteczność odczytu ustrukturyzowanych odpowiedzi modelu po zastosowaniu pełnego potoku naprawczego.</a:t>
             </a:r>
-            <a:endParaRPr lang="en-US" sz="900" dirty="0"/>
+            <a:endParaRPr lang="pl-PL" sz="1100" noProof="0" dirty="0"/>
           </a:p>
         </p:txBody>
       </p:sp>
@@ -5607,7 +6222,7 @@
 </p:sld>
 </file>
 
-<file path=ppt/slides/slide7.xml><?xml version="1.0" encoding="utf-8"?>
+<file path=ppt/slides/slide8.xml><?xml version="1.0" encoding="utf-8"?>
 <p:sld xmlns:a="http://schemas.openxmlformats.org/drawingml/2006/main" xmlns:r="http://schemas.openxmlformats.org/officeDocument/2006/relationships" xmlns:p="http://schemas.openxmlformats.org/presentationml/2006/main" showMasterSp="0">
   <p:cSld name="Slide 7">
     <p:bg>
@@ -6507,11 +7122,10 @@
           <a:bodyPr wrap="square" lIns="0" tIns="0" rIns="0" bIns="0" rtlCol="0" anchor="t"/>
           <a:lstStyle/>
           <a:p>
-            <a:pPr marL="0" indent="0" algn="l">
+            <a:pPr>
               <a:lnSpc>
                 <a:spcPts val="1750"/>
               </a:lnSpc>
-              <a:buNone/>
             </a:pPr>
             <a:r>
               <a:rPr lang="en-US" sz="1100" b="1" dirty="0">
@@ -6533,7 +7147,18 @@
                 <a:ea typeface="Source Serif 4" pitchFamily="34" charset="-122"/>
                 <a:cs typeface="Source Serif 4" pitchFamily="34" charset="-120"/>
               </a:rPr>
-              <a:t> przewyższa wynik PL-RoBERTa-Large na zbiorze MIPD — znaczący wynik dla modelu 4,5B.</a:t>
+              <a:t> </a:t>
+            </a:r>
+            <a:r>
+              <a:rPr lang="pl-PL" sz="1100" dirty="0">
+                <a:solidFill>
+                  <a:srgbClr val="000000"/>
+                </a:solidFill>
+                <a:latin typeface="Source Serif 4" pitchFamily="34" charset="0"/>
+                <a:ea typeface="Source Serif 4" pitchFamily="34" charset="-122"/>
+                <a:cs typeface="Source Serif 4" pitchFamily="34" charset="-120"/>
+              </a:rPr>
+              <a:t>konkurencyjne wobec raportowanych w literaturze, mimo zastosowania lokalnego modelu 4,5B</a:t>
             </a:r>
             <a:endParaRPr lang="en-US" sz="1100" dirty="0"/>
           </a:p>
@@ -6646,7 +7271,7 @@
 </p:sld>
 </file>
 
-<file path=ppt/slides/slide8.xml><?xml version="1.0" encoding="utf-8"?>
+<file path=ppt/slides/slide9.xml><?xml version="1.0" encoding="utf-8"?>
 <p:sld xmlns:a="http://schemas.openxmlformats.org/drawingml/2006/main" xmlns:r="http://schemas.openxmlformats.org/officeDocument/2006/relationships" xmlns:p="http://schemas.openxmlformats.org/presentationml/2006/main" showMasterSp="0">
   <p:cSld name="Slide 8">
     <p:bg>

</xml_diff>